<commit_message>
add envio da apresnetaçao e upload dos arquivos
</commit_message>
<xml_diff>
--- a/01_Preprocessing/preprocessamento_diabetes.pptx
+++ b/01_Preprocessing/preprocessamento_diabetes.pptx
@@ -409,11 +409,11 @@
         </c:ser>
         <c:gapWidth val="150"/>
         <c:overlap val="0"/>
-        <c:axId val="64806978"/>
-        <c:axId val="36761290"/>
+        <c:axId val="95884327"/>
+        <c:axId val="1947070"/>
       </c:barChart>
       <c:catAx>
-        <c:axId val="64806978"/>
+        <c:axId val="95884327"/>
         <c:scaling>
           <c:orientation val="minMax"/>
         </c:scaling>
@@ -446,7 +446,7 @@
             </a:pPr>
           </a:p>
         </c:txPr>
-        <c:crossAx val="36761290"/>
+        <c:crossAx val="1947070"/>
         <c:crosses val="autoZero"/>
         <c:auto val="1"/>
         <c:lblAlgn val="ctr"/>
@@ -454,7 +454,7 @@
         <c:noMultiLvlLbl val="0"/>
       </c:catAx>
       <c:valAx>
-        <c:axId val="36761290"/>
+        <c:axId val="1947070"/>
         <c:scaling>
           <c:orientation val="minMax"/>
         </c:scaling>
@@ -533,7 +533,7 @@
             </a:pPr>
           </a:p>
         </c:txPr>
-        <c:crossAx val="64806978"/>
+        <c:crossAx val="95884327"/>
         <c:crosses val="autoZero"/>
         <c:crossBetween val="between"/>
       </c:valAx>
@@ -672,8 +672,8 @@
         </c:ser>
         <c:gapWidth val="150"/>
         <c:overlap val="0"/>
-        <c:axId val="54231685"/>
-        <c:axId val="80537121"/>
+        <c:axId val="29991184"/>
+        <c:axId val="41371946"/>
       </c:barChart>
       <c:lineChart>
         <c:grouping val="standard"/>
@@ -793,11 +793,11 @@
           </c:spPr>
         </c:hiLowLines>
         <c:marker val="0"/>
-        <c:axId val="54231685"/>
-        <c:axId val="80537121"/>
+        <c:axId val="29991184"/>
+        <c:axId val="41371946"/>
       </c:lineChart>
       <c:catAx>
-        <c:axId val="54231685"/>
+        <c:axId val="29991184"/>
         <c:scaling>
           <c:orientation val="minMax"/>
         </c:scaling>
@@ -830,7 +830,7 @@
             </a:pPr>
           </a:p>
         </c:txPr>
-        <c:crossAx val="80537121"/>
+        <c:crossAx val="41371946"/>
         <c:crosses val="autoZero"/>
         <c:auto val="1"/>
         <c:lblAlgn val="ctr"/>
@@ -838,7 +838,7 @@
         <c:noMultiLvlLbl val="0"/>
       </c:catAx>
       <c:valAx>
-        <c:axId val="80537121"/>
+        <c:axId val="41371946"/>
         <c:scaling>
           <c:orientation val="minMax"/>
         </c:scaling>
@@ -917,7 +917,7 @@
             </a:pPr>
           </a:p>
         </c:txPr>
-        <c:crossAx val="54231685"/>
+        <c:crossAx val="29991184"/>
         <c:crosses val="autoZero"/>
         <c:crossBetween val="between"/>
       </c:valAx>
@@ -1010,24 +1010,36 @@
             <a:noAutofit/>
           </a:bodyPr>
           <a:p>
-            <a:r>
-              <a:rPr lang="pt-BR" sz="1800" b="0" u="none" strike="noStrike">
-                <a:solidFill>
-                  <a:schemeClr val="dk1"/>
-                </a:solidFill>
-                <a:effectLst/>
-                <a:uFillTx/>
-                <a:latin typeface="Calibri"/>
-              </a:rPr>
-              <a:t>Clique para mover o slide</a:t>
-            </a:r>
-            <a:endParaRPr lang="pt-BR" sz="1800" b="0" u="none" strike="noStrike">
-              <a:solidFill>
-                <a:schemeClr val="dk1"/>
-              </a:solidFill>
-              <a:effectLst/>
-              <a:uFillTx/>
-              <a:latin typeface="Calibri"/>
+            <a:pPr algn="ctr"/>
+            <a:r>
+              <a:rPr lang="pt-BR" sz="4400" b="0" u="none" strike="noStrike">
+                <a:solidFill>
+                  <a:srgbClr val="000000"/>
+                </a:solidFill>
+                <a:effectLst/>
+                <a:uFillTx/>
+                <a:latin typeface="Arial"/>
+              </a:rPr>
+              <a:t>Clique para </a:t>
+            </a:r>
+            <a:r>
+              <a:rPr lang="pt-BR" sz="4400" b="0" u="none" strike="noStrike">
+                <a:solidFill>
+                  <a:srgbClr val="000000"/>
+                </a:solidFill>
+                <a:effectLst/>
+                <a:uFillTx/>
+                <a:latin typeface="Arial"/>
+              </a:rPr>
+              <a:t>mover o slide</a:t>
+            </a:r>
+            <a:endParaRPr lang="pt-BR" sz="4400" b="0" u="none" strike="noStrike">
+              <a:solidFill>
+                <a:srgbClr val="000000"/>
+              </a:solidFill>
+              <a:effectLst/>
+              <a:uFillTx/>
+              <a:latin typeface="Arial"/>
             </a:endParaRPr>
           </a:p>
         </p:txBody>
@@ -1072,7 +1084,18 @@
                 <a:uFillTx/>
                 <a:latin typeface="Arial"/>
               </a:rPr>
-              <a:t>Clique para editar o formato de notas</a:t>
+              <a:t>Clique para editar o formato de </a:t>
+            </a:r>
+            <a:r>
+              <a:rPr lang="pt-BR" sz="2000" b="0" u="none" strike="noStrike">
+                <a:solidFill>
+                  <a:srgbClr val="000000"/>
+                </a:solidFill>
+                <a:effectLst/>
+                <a:uFillTx/>
+                <a:latin typeface="Arial"/>
+              </a:rPr>
+              <a:t>notas</a:t>
             </a:r>
             <a:endParaRPr lang="pt-BR" sz="2000" b="0" u="none" strike="noStrike">
               <a:solidFill>
@@ -1314,7 +1337,7 @@
             <a:pPr indent="0" algn="r">
               <a:buNone/>
             </a:pPr>
-            <a:fld id="{AA2196A1-78FA-4FC4-9C8B-2FDE3ECD3CC1}" type="slidenum">
+            <a:fld id="{40C36AEA-C192-4F7E-BC9C-B5825D84A5C9}" type="slidenum">
               <a:rPr lang="pt-BR" sz="1400" b="0" u="none" strike="noStrike">
                 <a:solidFill>
                   <a:srgbClr val="000000"/>
@@ -1372,7 +1395,7 @@
         <p:spPr>
           <a:xfrm>
             <a:off x="685800" y="1143000"/>
-            <a:ext cx="5486040" cy="3085920"/>
+            <a:ext cx="5485680" cy="3085560"/>
           </a:xfrm>
           <a:prstGeom prst="rect">
             <a:avLst/>
@@ -1395,7 +1418,7 @@
         <p:spPr>
           <a:xfrm>
             <a:off x="685800" y="4400640"/>
-            <a:ext cx="5486040" cy="3600000"/>
+            <a:ext cx="5485680" cy="3599640"/>
           </a:xfrm>
           <a:prstGeom prst="rect">
             <a:avLst/>
@@ -1437,7 +1460,7 @@
         <p:spPr>
           <a:xfrm>
             <a:off x="3884760" y="8685360"/>
-            <a:ext cx="2971440" cy="458280"/>
+            <a:ext cx="2971080" cy="457920"/>
           </a:xfrm>
           <a:prstGeom prst="rect">
             <a:avLst/>
@@ -1457,6 +1480,9 @@
                 <a:spcPct val="100000"/>
               </a:lnSpc>
               <a:buNone/>
+              <a:tabLst>
+                <a:tab algn="l" pos="0"/>
+              </a:tabLst>
               <a:defRPr lang="en-US" sz="1200" b="0" u="none" strike="noStrike">
                 <a:solidFill>
                   <a:schemeClr val="dk1"/>
@@ -1474,8 +1500,11 @@
                 <a:spcPct val="100000"/>
               </a:lnSpc>
               <a:buNone/>
-            </a:pPr>
-            <a:fld id="{9DFAF9D6-2A5C-49ED-9E7E-68F664C15C04}" type="slidenum">
+              <a:tabLst>
+                <a:tab algn="l" pos="0"/>
+              </a:tabLst>
+            </a:pPr>
+            <a:fld id="{371BECA5-56FB-4BD8-94F7-7C078958A8BE}" type="slidenum">
               <a:rPr lang="en-US" sz="1200" b="0" u="none" strike="noStrike">
                 <a:solidFill>
                   <a:schemeClr val="dk1"/>
@@ -1533,7 +1562,7 @@
         <p:spPr>
           <a:xfrm>
             <a:off x="685800" y="1143000"/>
-            <a:ext cx="5486040" cy="3085920"/>
+            <a:ext cx="5485680" cy="3085560"/>
           </a:xfrm>
           <a:prstGeom prst="rect">
             <a:avLst/>
@@ -1556,7 +1585,7 @@
         <p:spPr>
           <a:xfrm>
             <a:off x="685800" y="4400640"/>
-            <a:ext cx="5486040" cy="3600000"/>
+            <a:ext cx="5485680" cy="3599640"/>
           </a:xfrm>
           <a:prstGeom prst="rect">
             <a:avLst/>
@@ -1598,7 +1627,7 @@
         <p:spPr>
           <a:xfrm>
             <a:off x="3884760" y="8685360"/>
-            <a:ext cx="2971440" cy="458280"/>
+            <a:ext cx="2971080" cy="457920"/>
           </a:xfrm>
           <a:prstGeom prst="rect">
             <a:avLst/>
@@ -1618,6 +1647,9 @@
                 <a:spcPct val="100000"/>
               </a:lnSpc>
               <a:buNone/>
+              <a:tabLst>
+                <a:tab algn="l" pos="0"/>
+              </a:tabLst>
               <a:defRPr lang="en-US" sz="1200" b="0" u="none" strike="noStrike">
                 <a:solidFill>
                   <a:schemeClr val="dk1"/>
@@ -1635,8 +1667,11 @@
                 <a:spcPct val="100000"/>
               </a:lnSpc>
               <a:buNone/>
-            </a:pPr>
-            <a:fld id="{D049FE4D-F8FE-4AD1-83CB-448A19441A8E}" type="slidenum">
+              <a:tabLst>
+                <a:tab algn="l" pos="0"/>
+              </a:tabLst>
+            </a:pPr>
+            <a:fld id="{4F9F245A-DEEB-4A4D-BFDA-88EF2871F6E5}" type="slidenum">
               <a:rPr lang="en-US" sz="1200" b="0" u="none" strike="noStrike">
                 <a:solidFill>
                   <a:schemeClr val="dk1"/>
@@ -1694,7 +1729,7 @@
         <p:spPr>
           <a:xfrm>
             <a:off x="685800" y="1143000"/>
-            <a:ext cx="5486040" cy="3085920"/>
+            <a:ext cx="5485680" cy="3085560"/>
           </a:xfrm>
           <a:prstGeom prst="rect">
             <a:avLst/>
@@ -1717,7 +1752,7 @@
         <p:spPr>
           <a:xfrm>
             <a:off x="685800" y="4400640"/>
-            <a:ext cx="5486040" cy="3600000"/>
+            <a:ext cx="5485680" cy="3599640"/>
           </a:xfrm>
           <a:prstGeom prst="rect">
             <a:avLst/>
@@ -1759,7 +1794,7 @@
         <p:spPr>
           <a:xfrm>
             <a:off x="3884760" y="8685360"/>
-            <a:ext cx="2971440" cy="458280"/>
+            <a:ext cx="2971080" cy="457920"/>
           </a:xfrm>
           <a:prstGeom prst="rect">
             <a:avLst/>
@@ -1779,6 +1814,9 @@
                 <a:spcPct val="100000"/>
               </a:lnSpc>
               <a:buNone/>
+              <a:tabLst>
+                <a:tab algn="l" pos="0"/>
+              </a:tabLst>
               <a:defRPr lang="en-US" sz="1200" b="0" u="none" strike="noStrike">
                 <a:solidFill>
                   <a:schemeClr val="dk1"/>
@@ -1796,8 +1834,11 @@
                 <a:spcPct val="100000"/>
               </a:lnSpc>
               <a:buNone/>
-            </a:pPr>
-            <a:fld id="{95AE4779-00A3-4DA5-AA80-1B1BACD53F2B}" type="slidenum">
+              <a:tabLst>
+                <a:tab algn="l" pos="0"/>
+              </a:tabLst>
+            </a:pPr>
+            <a:fld id="{A7A00631-B5C3-4846-A14A-AF76D67CA703}" type="slidenum">
               <a:rPr lang="en-US" sz="1200" b="0" u="none" strike="noStrike">
                 <a:solidFill>
                   <a:schemeClr val="dk1"/>
@@ -1855,7 +1896,7 @@
         <p:spPr>
           <a:xfrm>
             <a:off x="685800" y="1143000"/>
-            <a:ext cx="5486040" cy="3085920"/>
+            <a:ext cx="5485680" cy="3085560"/>
           </a:xfrm>
           <a:prstGeom prst="rect">
             <a:avLst/>
@@ -1878,7 +1919,7 @@
         <p:spPr>
           <a:xfrm>
             <a:off x="685800" y="4400640"/>
-            <a:ext cx="5486040" cy="3600000"/>
+            <a:ext cx="5485680" cy="3599640"/>
           </a:xfrm>
           <a:prstGeom prst="rect">
             <a:avLst/>
@@ -1920,7 +1961,7 @@
         <p:spPr>
           <a:xfrm>
             <a:off x="3884760" y="8685360"/>
-            <a:ext cx="2971440" cy="458280"/>
+            <a:ext cx="2971080" cy="457920"/>
           </a:xfrm>
           <a:prstGeom prst="rect">
             <a:avLst/>
@@ -1940,6 +1981,9 @@
                 <a:spcPct val="100000"/>
               </a:lnSpc>
               <a:buNone/>
+              <a:tabLst>
+                <a:tab algn="l" pos="0"/>
+              </a:tabLst>
               <a:defRPr lang="en-US" sz="1200" b="0" u="none" strike="noStrike">
                 <a:solidFill>
                   <a:schemeClr val="dk1"/>
@@ -1957,8 +2001,11 @@
                 <a:spcPct val="100000"/>
               </a:lnSpc>
               <a:buNone/>
-            </a:pPr>
-            <a:fld id="{C00154C4-B343-4020-AAC9-74071C3CE961}" type="slidenum">
+              <a:tabLst>
+                <a:tab algn="l" pos="0"/>
+              </a:tabLst>
+            </a:pPr>
+            <a:fld id="{8048738F-F928-4B41-AF0E-2D0E3CBE4B44}" type="slidenum">
               <a:rPr lang="en-US" sz="1200" b="0" u="none" strike="noStrike">
                 <a:solidFill>
                   <a:schemeClr val="dk1"/>
@@ -2016,7 +2063,7 @@
         <p:spPr>
           <a:xfrm>
             <a:off x="685800" y="1143000"/>
-            <a:ext cx="5486040" cy="3085920"/>
+            <a:ext cx="5485680" cy="3085560"/>
           </a:xfrm>
           <a:prstGeom prst="rect">
             <a:avLst/>
@@ -2039,7 +2086,7 @@
         <p:spPr>
           <a:xfrm>
             <a:off x="685800" y="4400640"/>
-            <a:ext cx="5486040" cy="3600000"/>
+            <a:ext cx="5485680" cy="3599640"/>
           </a:xfrm>
           <a:prstGeom prst="rect">
             <a:avLst/>
@@ -2081,7 +2128,7 @@
         <p:spPr>
           <a:xfrm>
             <a:off x="3884760" y="8685360"/>
-            <a:ext cx="2971440" cy="458280"/>
+            <a:ext cx="2971080" cy="457920"/>
           </a:xfrm>
           <a:prstGeom prst="rect">
             <a:avLst/>
@@ -2101,6 +2148,9 @@
                 <a:spcPct val="100000"/>
               </a:lnSpc>
               <a:buNone/>
+              <a:tabLst>
+                <a:tab algn="l" pos="0"/>
+              </a:tabLst>
               <a:defRPr lang="en-US" sz="1200" b="0" u="none" strike="noStrike">
                 <a:solidFill>
                   <a:schemeClr val="dk1"/>
@@ -2118,8 +2168,11 @@
                 <a:spcPct val="100000"/>
               </a:lnSpc>
               <a:buNone/>
-            </a:pPr>
-            <a:fld id="{C180DB8B-3781-459F-BF51-767308DB93E7}" type="slidenum">
+              <a:tabLst>
+                <a:tab algn="l" pos="0"/>
+              </a:tabLst>
+            </a:pPr>
+            <a:fld id="{98029416-49D7-45AD-8B0A-B77B8C85A6DF}" type="slidenum">
               <a:rPr lang="en-US" sz="1200" b="0" u="none" strike="noStrike">
                 <a:solidFill>
                   <a:schemeClr val="dk1"/>
@@ -2177,7 +2230,7 @@
         <p:spPr>
           <a:xfrm>
             <a:off x="685800" y="1143000"/>
-            <a:ext cx="5486040" cy="3085920"/>
+            <a:ext cx="5485680" cy="3085560"/>
           </a:xfrm>
           <a:prstGeom prst="rect">
             <a:avLst/>
@@ -2200,7 +2253,7 @@
         <p:spPr>
           <a:xfrm>
             <a:off x="685800" y="4400640"/>
-            <a:ext cx="5486040" cy="3600000"/>
+            <a:ext cx="5485680" cy="3599640"/>
           </a:xfrm>
           <a:prstGeom prst="rect">
             <a:avLst/>
@@ -2242,7 +2295,7 @@
         <p:spPr>
           <a:xfrm>
             <a:off x="3884760" y="8685360"/>
-            <a:ext cx="2971440" cy="458280"/>
+            <a:ext cx="2971080" cy="457920"/>
           </a:xfrm>
           <a:prstGeom prst="rect">
             <a:avLst/>
@@ -2262,6 +2315,9 @@
                 <a:spcPct val="100000"/>
               </a:lnSpc>
               <a:buNone/>
+              <a:tabLst>
+                <a:tab algn="l" pos="0"/>
+              </a:tabLst>
               <a:defRPr lang="en-US" sz="1200" b="0" u="none" strike="noStrike">
                 <a:solidFill>
                   <a:schemeClr val="dk1"/>
@@ -2279,8 +2335,11 @@
                 <a:spcPct val="100000"/>
               </a:lnSpc>
               <a:buNone/>
-            </a:pPr>
-            <a:fld id="{91D9B25D-3D27-4EA3-8712-39D76FC01766}" type="slidenum">
+              <a:tabLst>
+                <a:tab algn="l" pos="0"/>
+              </a:tabLst>
+            </a:pPr>
+            <a:fld id="{EF4EB59F-7137-4C38-9451-A78A16B135A5}" type="slidenum">
               <a:rPr lang="en-US" sz="1200" b="0" u="none" strike="noStrike">
                 <a:solidFill>
                   <a:schemeClr val="dk1"/>
@@ -2338,7 +2397,7 @@
         <p:spPr>
           <a:xfrm>
             <a:off x="685800" y="1143000"/>
-            <a:ext cx="5486040" cy="3085920"/>
+            <a:ext cx="5485680" cy="3085560"/>
           </a:xfrm>
           <a:prstGeom prst="rect">
             <a:avLst/>
@@ -2361,7 +2420,7 @@
         <p:spPr>
           <a:xfrm>
             <a:off x="685800" y="4400640"/>
-            <a:ext cx="5486040" cy="3600000"/>
+            <a:ext cx="5485680" cy="3599640"/>
           </a:xfrm>
           <a:prstGeom prst="rect">
             <a:avLst/>
@@ -2403,7 +2462,7 @@
         <p:spPr>
           <a:xfrm>
             <a:off x="3884760" y="8685360"/>
-            <a:ext cx="2971440" cy="458280"/>
+            <a:ext cx="2971080" cy="457920"/>
           </a:xfrm>
           <a:prstGeom prst="rect">
             <a:avLst/>
@@ -2423,6 +2482,9 @@
                 <a:spcPct val="100000"/>
               </a:lnSpc>
               <a:buNone/>
+              <a:tabLst>
+                <a:tab algn="l" pos="0"/>
+              </a:tabLst>
               <a:defRPr lang="en-US" sz="1200" b="0" u="none" strike="noStrike">
                 <a:solidFill>
                   <a:schemeClr val="dk1"/>
@@ -2440,8 +2502,11 @@
                 <a:spcPct val="100000"/>
               </a:lnSpc>
               <a:buNone/>
-            </a:pPr>
-            <a:fld id="{FEE8A3F6-E45E-49AC-83B1-133E46E642ED}" type="slidenum">
+              <a:tabLst>
+                <a:tab algn="l" pos="0"/>
+              </a:tabLst>
+            </a:pPr>
+            <a:fld id="{7C730E27-7620-46DF-8AF5-906428B8F1C1}" type="slidenum">
               <a:rPr lang="en-US" sz="1200" b="0" u="none" strike="noStrike">
                 <a:solidFill>
                   <a:schemeClr val="dk1"/>
@@ -2499,7 +2564,7 @@
         <p:spPr>
           <a:xfrm>
             <a:off x="685800" y="1143000"/>
-            <a:ext cx="5486040" cy="3085920"/>
+            <a:ext cx="5485680" cy="3085560"/>
           </a:xfrm>
           <a:prstGeom prst="rect">
             <a:avLst/>
@@ -2522,7 +2587,7 @@
         <p:spPr>
           <a:xfrm>
             <a:off x="685800" y="4400640"/>
-            <a:ext cx="5486040" cy="3600000"/>
+            <a:ext cx="5485680" cy="3599640"/>
           </a:xfrm>
           <a:prstGeom prst="rect">
             <a:avLst/>
@@ -2564,7 +2629,7 @@
         <p:spPr>
           <a:xfrm>
             <a:off x="3884760" y="8685360"/>
-            <a:ext cx="2971440" cy="458280"/>
+            <a:ext cx="2971080" cy="457920"/>
           </a:xfrm>
           <a:prstGeom prst="rect">
             <a:avLst/>
@@ -2584,6 +2649,9 @@
                 <a:spcPct val="100000"/>
               </a:lnSpc>
               <a:buNone/>
+              <a:tabLst>
+                <a:tab algn="l" pos="0"/>
+              </a:tabLst>
               <a:defRPr lang="en-US" sz="1200" b="0" u="none" strike="noStrike">
                 <a:solidFill>
                   <a:schemeClr val="dk1"/>
@@ -2601,8 +2669,11 @@
                 <a:spcPct val="100000"/>
               </a:lnSpc>
               <a:buNone/>
-            </a:pPr>
-            <a:fld id="{D26865D6-7D74-4C0A-A325-423446DC4324}" type="slidenum">
+              <a:tabLst>
+                <a:tab algn="l" pos="0"/>
+              </a:tabLst>
+            </a:pPr>
+            <a:fld id="{989C7696-905C-4E1C-9F3B-2131522BC0F3}" type="slidenum">
               <a:rPr lang="en-US" sz="1200" b="0" u="none" strike="noStrike">
                 <a:solidFill>
                   <a:schemeClr val="dk1"/>
@@ -2660,7 +2731,7 @@
         <p:spPr>
           <a:xfrm>
             <a:off x="685800" y="1143000"/>
-            <a:ext cx="5486040" cy="3085920"/>
+            <a:ext cx="5485680" cy="3085560"/>
           </a:xfrm>
           <a:prstGeom prst="rect">
             <a:avLst/>
@@ -2683,7 +2754,7 @@
         <p:spPr>
           <a:xfrm>
             <a:off x="685800" y="4400640"/>
-            <a:ext cx="5486040" cy="3600000"/>
+            <a:ext cx="5485680" cy="3599640"/>
           </a:xfrm>
           <a:prstGeom prst="rect">
             <a:avLst/>
@@ -2725,7 +2796,7 @@
         <p:spPr>
           <a:xfrm>
             <a:off x="3884760" y="8685360"/>
-            <a:ext cx="2971440" cy="458280"/>
+            <a:ext cx="2971080" cy="457920"/>
           </a:xfrm>
           <a:prstGeom prst="rect">
             <a:avLst/>
@@ -2745,6 +2816,9 @@
                 <a:spcPct val="100000"/>
               </a:lnSpc>
               <a:buNone/>
+              <a:tabLst>
+                <a:tab algn="l" pos="0"/>
+              </a:tabLst>
               <a:defRPr lang="en-US" sz="1200" b="0" u="none" strike="noStrike">
                 <a:solidFill>
                   <a:schemeClr val="dk1"/>
@@ -2762,8 +2836,11 @@
                 <a:spcPct val="100000"/>
               </a:lnSpc>
               <a:buNone/>
-            </a:pPr>
-            <a:fld id="{DB1110F3-11D5-4ADF-8B2F-4AEEE9E0FF23}" type="slidenum">
+              <a:tabLst>
+                <a:tab algn="l" pos="0"/>
+              </a:tabLst>
+            </a:pPr>
+            <a:fld id="{7A78621C-E06F-448B-98FF-F8288F0401E0}" type="slidenum">
               <a:rPr lang="en-US" sz="1200" b="0" u="none" strike="noStrike">
                 <a:solidFill>
                   <a:schemeClr val="dk1"/>
@@ -2821,7 +2898,7 @@
         <p:spPr>
           <a:xfrm>
             <a:off x="685800" y="1143000"/>
-            <a:ext cx="5486040" cy="3085920"/>
+            <a:ext cx="5485680" cy="3085560"/>
           </a:xfrm>
           <a:prstGeom prst="rect">
             <a:avLst/>
@@ -2844,7 +2921,7 @@
         <p:spPr>
           <a:xfrm>
             <a:off x="685800" y="4400640"/>
-            <a:ext cx="5486040" cy="3600000"/>
+            <a:ext cx="5485680" cy="3599640"/>
           </a:xfrm>
           <a:prstGeom prst="rect">
             <a:avLst/>
@@ -2886,7 +2963,7 @@
         <p:spPr>
           <a:xfrm>
             <a:off x="3884760" y="8685360"/>
-            <a:ext cx="2971440" cy="458280"/>
+            <a:ext cx="2971080" cy="457920"/>
           </a:xfrm>
           <a:prstGeom prst="rect">
             <a:avLst/>
@@ -2906,6 +2983,9 @@
                 <a:spcPct val="100000"/>
               </a:lnSpc>
               <a:buNone/>
+              <a:tabLst>
+                <a:tab algn="l" pos="0"/>
+              </a:tabLst>
               <a:defRPr lang="en-US" sz="1200" b="0" u="none" strike="noStrike">
                 <a:solidFill>
                   <a:schemeClr val="dk1"/>
@@ -2923,8 +3003,11 @@
                 <a:spcPct val="100000"/>
               </a:lnSpc>
               <a:buNone/>
-            </a:pPr>
-            <a:fld id="{029AB578-46D7-4BA1-880A-98B05780A4EF}" type="slidenum">
+              <a:tabLst>
+                <a:tab algn="l" pos="0"/>
+              </a:tabLst>
+            </a:pPr>
+            <a:fld id="{342A3FFD-2EFD-4F83-BCA3-213A85D9C84B}" type="slidenum">
               <a:rPr lang="en-US" sz="1200" b="0" u="none" strike="noStrike">
                 <a:solidFill>
                   <a:schemeClr val="dk1"/>
@@ -3026,60 +3109,412 @@
             <a:noAutofit/>
           </a:bodyPr>
           <a:p>
-            <a:pPr indent="0">
+            <a:pPr indent="0" algn="ctr">
               <a:buNone/>
             </a:pPr>
             <a:r>
-              <a:rPr lang="pt-BR" sz="1800" b="0" u="none" strike="noStrike">
-                <a:solidFill>
-                  <a:schemeClr val="dk1"/>
-                </a:solidFill>
-                <a:effectLst/>
-                <a:uFillTx/>
-                <a:latin typeface="Calibri"/>
-              </a:rPr>
-              <a:t>Clique para </a:t>
-            </a:r>
-            <a:r>
-              <a:rPr lang="pt-BR" sz="1800" b="0" u="none" strike="noStrike">
-                <a:solidFill>
-                  <a:schemeClr val="dk1"/>
-                </a:solidFill>
-                <a:effectLst/>
-                <a:uFillTx/>
-                <a:latin typeface="Calibri"/>
-              </a:rPr>
-              <a:t>editar o </a:t>
-            </a:r>
-            <a:r>
-              <a:rPr lang="pt-BR" sz="1800" b="0" u="none" strike="noStrike">
-                <a:solidFill>
-                  <a:schemeClr val="dk1"/>
-                </a:solidFill>
-                <a:effectLst/>
-                <a:uFillTx/>
-                <a:latin typeface="Calibri"/>
-              </a:rPr>
-              <a:t>formato do </a:t>
-            </a:r>
-            <a:r>
-              <a:rPr lang="pt-BR" sz="1800" b="0" u="none" strike="noStrike">
-                <a:solidFill>
-                  <a:schemeClr val="dk1"/>
-                </a:solidFill>
-                <a:effectLst/>
-                <a:uFillTx/>
-                <a:latin typeface="Calibri"/>
-              </a:rPr>
-              <a:t>texto do título</a:t>
-            </a:r>
-            <a:endParaRPr lang="pt-BR" sz="1800" b="0" u="none" strike="noStrike">
-              <a:solidFill>
-                <a:schemeClr val="dk1"/>
-              </a:solidFill>
-              <a:effectLst/>
-              <a:uFillTx/>
-              <a:latin typeface="Calibri"/>
+              <a:rPr lang="pt-BR" sz="4400" b="0" u="none" strike="noStrike">
+                <a:solidFill>
+                  <a:srgbClr val="000000"/>
+                </a:solidFill>
+                <a:effectLst/>
+                <a:uFillTx/>
+                <a:latin typeface="Arial"/>
+              </a:rPr>
+              <a:t>C</a:t>
+            </a:r>
+            <a:r>
+              <a:rPr lang="pt-BR" sz="4400" b="0" u="none" strike="noStrike">
+                <a:solidFill>
+                  <a:srgbClr val="000000"/>
+                </a:solidFill>
+                <a:effectLst/>
+                <a:uFillTx/>
+                <a:latin typeface="Arial"/>
+              </a:rPr>
+              <a:t>li</a:t>
+            </a:r>
+            <a:r>
+              <a:rPr lang="pt-BR" sz="4400" b="0" u="none" strike="noStrike">
+                <a:solidFill>
+                  <a:srgbClr val="000000"/>
+                </a:solidFill>
+                <a:effectLst/>
+                <a:uFillTx/>
+                <a:latin typeface="Arial"/>
+              </a:rPr>
+              <a:t>q</a:t>
+            </a:r>
+            <a:r>
+              <a:rPr lang="pt-BR" sz="4400" b="0" u="none" strike="noStrike">
+                <a:solidFill>
+                  <a:srgbClr val="000000"/>
+                </a:solidFill>
+                <a:effectLst/>
+                <a:uFillTx/>
+                <a:latin typeface="Arial"/>
+              </a:rPr>
+              <a:t>u</a:t>
+            </a:r>
+            <a:r>
+              <a:rPr lang="pt-BR" sz="4400" b="0" u="none" strike="noStrike">
+                <a:solidFill>
+                  <a:srgbClr val="000000"/>
+                </a:solidFill>
+                <a:effectLst/>
+                <a:uFillTx/>
+                <a:latin typeface="Arial"/>
+              </a:rPr>
+              <a:t>e </a:t>
+            </a:r>
+            <a:r>
+              <a:rPr lang="pt-BR" sz="4400" b="0" u="none" strike="noStrike">
+                <a:solidFill>
+                  <a:srgbClr val="000000"/>
+                </a:solidFill>
+                <a:effectLst/>
+                <a:uFillTx/>
+                <a:latin typeface="Arial"/>
+              </a:rPr>
+              <a:t>p</a:t>
+            </a:r>
+            <a:r>
+              <a:rPr lang="pt-BR" sz="4400" b="0" u="none" strike="noStrike">
+                <a:solidFill>
+                  <a:srgbClr val="000000"/>
+                </a:solidFill>
+                <a:effectLst/>
+                <a:uFillTx/>
+                <a:latin typeface="Arial"/>
+              </a:rPr>
+              <a:t>a</a:t>
+            </a:r>
+            <a:r>
+              <a:rPr lang="pt-BR" sz="4400" b="0" u="none" strike="noStrike">
+                <a:solidFill>
+                  <a:srgbClr val="000000"/>
+                </a:solidFill>
+                <a:effectLst/>
+                <a:uFillTx/>
+                <a:latin typeface="Arial"/>
+              </a:rPr>
+              <a:t>r</a:t>
+            </a:r>
+            <a:r>
+              <a:rPr lang="pt-BR" sz="4400" b="0" u="none" strike="noStrike">
+                <a:solidFill>
+                  <a:srgbClr val="000000"/>
+                </a:solidFill>
+                <a:effectLst/>
+                <a:uFillTx/>
+                <a:latin typeface="Arial"/>
+              </a:rPr>
+              <a:t>a </a:t>
+            </a:r>
+            <a:r>
+              <a:rPr lang="pt-BR" sz="4400" b="0" u="none" strike="noStrike">
+                <a:solidFill>
+                  <a:srgbClr val="000000"/>
+                </a:solidFill>
+                <a:effectLst/>
+                <a:uFillTx/>
+                <a:latin typeface="Arial"/>
+              </a:rPr>
+              <a:t>e</a:t>
+            </a:r>
+            <a:r>
+              <a:rPr lang="pt-BR" sz="4400" b="0" u="none" strike="noStrike">
+                <a:solidFill>
+                  <a:srgbClr val="000000"/>
+                </a:solidFill>
+                <a:effectLst/>
+                <a:uFillTx/>
+                <a:latin typeface="Arial"/>
+              </a:rPr>
+              <a:t>d</a:t>
+            </a:r>
+            <a:r>
+              <a:rPr lang="pt-BR" sz="4400" b="0" u="none" strike="noStrike">
+                <a:solidFill>
+                  <a:srgbClr val="000000"/>
+                </a:solidFill>
+                <a:effectLst/>
+                <a:uFillTx/>
+                <a:latin typeface="Arial"/>
+              </a:rPr>
+              <a:t>it</a:t>
+            </a:r>
+            <a:r>
+              <a:rPr lang="pt-BR" sz="4400" b="0" u="none" strike="noStrike">
+                <a:solidFill>
+                  <a:srgbClr val="000000"/>
+                </a:solidFill>
+                <a:effectLst/>
+                <a:uFillTx/>
+                <a:latin typeface="Arial"/>
+              </a:rPr>
+              <a:t>a</a:t>
+            </a:r>
+            <a:r>
+              <a:rPr lang="pt-BR" sz="4400" b="0" u="none" strike="noStrike">
+                <a:solidFill>
+                  <a:srgbClr val="000000"/>
+                </a:solidFill>
+                <a:effectLst/>
+                <a:uFillTx/>
+                <a:latin typeface="Arial"/>
+              </a:rPr>
+              <a:t>r </a:t>
+            </a:r>
+            <a:r>
+              <a:rPr lang="pt-BR" sz="4400" b="0" u="none" strike="noStrike">
+                <a:solidFill>
+                  <a:srgbClr val="000000"/>
+                </a:solidFill>
+                <a:effectLst/>
+                <a:uFillTx/>
+                <a:latin typeface="Arial"/>
+              </a:rPr>
+              <a:t>o </a:t>
+            </a:r>
+            <a:r>
+              <a:rPr lang="pt-BR" sz="4400" b="0" u="none" strike="noStrike">
+                <a:solidFill>
+                  <a:srgbClr val="000000"/>
+                </a:solidFill>
+                <a:effectLst/>
+                <a:uFillTx/>
+                <a:latin typeface="Arial"/>
+              </a:rPr>
+              <a:t>f</a:t>
+            </a:r>
+            <a:r>
+              <a:rPr lang="pt-BR" sz="4400" b="0" u="none" strike="noStrike">
+                <a:solidFill>
+                  <a:srgbClr val="000000"/>
+                </a:solidFill>
+                <a:effectLst/>
+                <a:uFillTx/>
+                <a:latin typeface="Arial"/>
+              </a:rPr>
+              <a:t>o</a:t>
+            </a:r>
+            <a:r>
+              <a:rPr lang="pt-BR" sz="4400" b="0" u="none" strike="noStrike">
+                <a:solidFill>
+                  <a:srgbClr val="000000"/>
+                </a:solidFill>
+                <a:effectLst/>
+                <a:uFillTx/>
+                <a:latin typeface="Arial"/>
+              </a:rPr>
+              <a:t>r</a:t>
+            </a:r>
+            <a:r>
+              <a:rPr lang="pt-BR" sz="4400" b="0" u="none" strike="noStrike">
+                <a:solidFill>
+                  <a:srgbClr val="000000"/>
+                </a:solidFill>
+                <a:effectLst/>
+                <a:uFillTx/>
+                <a:latin typeface="Arial"/>
+              </a:rPr>
+              <a:t>m</a:t>
+            </a:r>
+            <a:r>
+              <a:rPr lang="pt-BR" sz="4400" b="0" u="none" strike="noStrike">
+                <a:solidFill>
+                  <a:srgbClr val="000000"/>
+                </a:solidFill>
+                <a:effectLst/>
+                <a:uFillTx/>
+                <a:latin typeface="Arial"/>
+              </a:rPr>
+              <a:t>a</a:t>
+            </a:r>
+            <a:r>
+              <a:rPr lang="pt-BR" sz="4400" b="0" u="none" strike="noStrike">
+                <a:solidFill>
+                  <a:srgbClr val="000000"/>
+                </a:solidFill>
+                <a:effectLst/>
+                <a:uFillTx/>
+                <a:latin typeface="Arial"/>
+              </a:rPr>
+              <a:t>t</a:t>
+            </a:r>
+            <a:r>
+              <a:rPr lang="pt-BR" sz="4400" b="0" u="none" strike="noStrike">
+                <a:solidFill>
+                  <a:srgbClr val="000000"/>
+                </a:solidFill>
+                <a:effectLst/>
+                <a:uFillTx/>
+                <a:latin typeface="Arial"/>
+              </a:rPr>
+              <a:t>o </a:t>
+            </a:r>
+            <a:r>
+              <a:rPr lang="pt-BR" sz="4400" b="0" u="none" strike="noStrike">
+                <a:solidFill>
+                  <a:srgbClr val="000000"/>
+                </a:solidFill>
+                <a:effectLst/>
+                <a:uFillTx/>
+                <a:latin typeface="Arial"/>
+              </a:rPr>
+              <a:t>d</a:t>
+            </a:r>
+            <a:r>
+              <a:rPr lang="pt-BR" sz="4400" b="0" u="none" strike="noStrike">
+                <a:solidFill>
+                  <a:srgbClr val="000000"/>
+                </a:solidFill>
+                <a:effectLst/>
+                <a:uFillTx/>
+                <a:latin typeface="Arial"/>
+              </a:rPr>
+              <a:t>o </a:t>
+            </a:r>
+            <a:r>
+              <a:rPr lang="pt-BR" sz="4400" b="0" u="none" strike="noStrike">
+                <a:solidFill>
+                  <a:srgbClr val="000000"/>
+                </a:solidFill>
+                <a:effectLst/>
+                <a:uFillTx/>
+                <a:latin typeface="Arial"/>
+              </a:rPr>
+              <a:t>t</a:t>
+            </a:r>
+            <a:r>
+              <a:rPr lang="pt-BR" sz="4400" b="0" u="none" strike="noStrike">
+                <a:solidFill>
+                  <a:srgbClr val="000000"/>
+                </a:solidFill>
+                <a:effectLst/>
+                <a:uFillTx/>
+                <a:latin typeface="Arial"/>
+              </a:rPr>
+              <a:t>e</a:t>
+            </a:r>
+            <a:r>
+              <a:rPr lang="pt-BR" sz="4400" b="0" u="none" strike="noStrike">
+                <a:solidFill>
+                  <a:srgbClr val="000000"/>
+                </a:solidFill>
+                <a:effectLst/>
+                <a:uFillTx/>
+                <a:latin typeface="Arial"/>
+              </a:rPr>
+              <a:t>x</a:t>
+            </a:r>
+            <a:r>
+              <a:rPr lang="pt-BR" sz="4400" b="0" u="none" strike="noStrike">
+                <a:solidFill>
+                  <a:srgbClr val="000000"/>
+                </a:solidFill>
+                <a:effectLst/>
+                <a:uFillTx/>
+                <a:latin typeface="Arial"/>
+              </a:rPr>
+              <a:t>t</a:t>
+            </a:r>
+            <a:r>
+              <a:rPr lang="pt-BR" sz="4400" b="0" u="none" strike="noStrike">
+                <a:solidFill>
+                  <a:srgbClr val="000000"/>
+                </a:solidFill>
+                <a:effectLst/>
+                <a:uFillTx/>
+                <a:latin typeface="Arial"/>
+              </a:rPr>
+              <a:t>o </a:t>
+            </a:r>
+            <a:r>
+              <a:rPr lang="pt-BR" sz="4400" b="0" u="none" strike="noStrike">
+                <a:solidFill>
+                  <a:srgbClr val="000000"/>
+                </a:solidFill>
+                <a:effectLst/>
+                <a:uFillTx/>
+                <a:latin typeface="Arial"/>
+              </a:rPr>
+              <a:t>d</a:t>
+            </a:r>
+            <a:r>
+              <a:rPr lang="pt-BR" sz="4400" b="0" u="none" strike="noStrike">
+                <a:solidFill>
+                  <a:srgbClr val="000000"/>
+                </a:solidFill>
+                <a:effectLst/>
+                <a:uFillTx/>
+                <a:latin typeface="Arial"/>
+              </a:rPr>
+              <a:t>o </a:t>
+            </a:r>
+            <a:r>
+              <a:rPr lang="pt-BR" sz="4400" b="0" u="none" strike="noStrike">
+                <a:solidFill>
+                  <a:srgbClr val="000000"/>
+                </a:solidFill>
+                <a:effectLst/>
+                <a:uFillTx/>
+                <a:latin typeface="Arial"/>
+              </a:rPr>
+              <a:t>tí</a:t>
+            </a:r>
+            <a:r>
+              <a:rPr lang="pt-BR" sz="4400" b="0" u="none" strike="noStrike">
+                <a:solidFill>
+                  <a:srgbClr val="000000"/>
+                </a:solidFill>
+                <a:effectLst/>
+                <a:uFillTx/>
+                <a:latin typeface="Arial"/>
+              </a:rPr>
+              <a:t>t</a:t>
+            </a:r>
+            <a:r>
+              <a:rPr lang="pt-BR" sz="4400" b="0" u="none" strike="noStrike">
+                <a:solidFill>
+                  <a:srgbClr val="000000"/>
+                </a:solidFill>
+                <a:effectLst/>
+                <a:uFillTx/>
+                <a:latin typeface="Arial"/>
+              </a:rPr>
+              <a:t>u</a:t>
+            </a:r>
+            <a:r>
+              <a:rPr lang="pt-BR" sz="4400" b="0" u="none" strike="noStrike">
+                <a:solidFill>
+                  <a:srgbClr val="000000"/>
+                </a:solidFill>
+                <a:effectLst/>
+                <a:uFillTx/>
+                <a:latin typeface="Arial"/>
+              </a:rPr>
+              <a:t>l</a:t>
+            </a:r>
+            <a:r>
+              <a:rPr lang="pt-BR" sz="4400" b="0" u="none" strike="noStrike">
+                <a:solidFill>
+                  <a:srgbClr val="000000"/>
+                </a:solidFill>
+                <a:effectLst/>
+                <a:uFillTx/>
+                <a:latin typeface="Arial"/>
+              </a:rPr>
+              <a:t>o</a:t>
+            </a:r>
+            <a:endParaRPr lang="pt-BR" sz="4400" b="0" u="none" strike="noStrike">
+              <a:solidFill>
+                <a:srgbClr val="000000"/>
+              </a:solidFill>
+              <a:effectLst/>
+              <a:uFillTx/>
+              <a:latin typeface="Arial"/>
             </a:endParaRPr>
           </a:p>
         </p:txBody>
@@ -3126,21 +3561,21 @@
             <a:r>
               <a:rPr lang="pt-BR" sz="3200" b="0" u="none" strike="noStrike">
                 <a:solidFill>
-                  <a:schemeClr val="dk1"/>
-                </a:solidFill>
-                <a:effectLst/>
-                <a:uFillTx/>
-                <a:latin typeface="Calibri"/>
+                  <a:srgbClr val="000000"/>
+                </a:solidFill>
+                <a:effectLst/>
+                <a:uFillTx/>
+                <a:latin typeface="Arial"/>
               </a:rPr>
               <a:t>Clique para editar o formato de texto dos tópicos</a:t>
             </a:r>
             <a:endParaRPr lang="pt-BR" sz="3200" b="0" u="none" strike="noStrike">
               <a:solidFill>
-                <a:schemeClr val="dk1"/>
-              </a:solidFill>
-              <a:effectLst/>
-              <a:uFillTx/>
-              <a:latin typeface="Calibri"/>
+                <a:srgbClr val="000000"/>
+              </a:solidFill>
+              <a:effectLst/>
+              <a:uFillTx/>
+              <a:latin typeface="Arial"/>
             </a:endParaRPr>
           </a:p>
           <a:p>
@@ -3156,23 +3591,23 @@
               <a:buChar char=""/>
             </a:pPr>
             <a:r>
-              <a:rPr lang="pt-BR" sz="2400" b="0" u="none" strike="noStrike">
-                <a:solidFill>
-                  <a:schemeClr val="dk1"/>
-                </a:solidFill>
-                <a:effectLst/>
-                <a:uFillTx/>
-                <a:latin typeface="Calibri"/>
+              <a:rPr lang="pt-BR" sz="2800" b="0" u="none" strike="noStrike">
+                <a:solidFill>
+                  <a:srgbClr val="000000"/>
+                </a:solidFill>
+                <a:effectLst/>
+                <a:uFillTx/>
+                <a:latin typeface="Arial"/>
               </a:rPr>
               <a:t>2.º nível de tópicos</a:t>
             </a:r>
-            <a:endParaRPr lang="pt-BR" sz="2400" b="0" u="none" strike="noStrike">
-              <a:solidFill>
-                <a:schemeClr val="dk1"/>
-              </a:solidFill>
-              <a:effectLst/>
-              <a:uFillTx/>
-              <a:latin typeface="Calibri"/>
+            <a:endParaRPr lang="pt-BR" sz="2800" b="0" u="none" strike="noStrike">
+              <a:solidFill>
+                <a:srgbClr val="000000"/>
+              </a:solidFill>
+              <a:effectLst/>
+              <a:uFillTx/>
+              <a:latin typeface="Arial"/>
             </a:endParaRPr>
           </a:p>
           <a:p>
@@ -3188,23 +3623,23 @@
               <a:buChar char=""/>
             </a:pPr>
             <a:r>
-              <a:rPr lang="pt-BR" sz="2000" b="0" u="none" strike="noStrike">
-                <a:solidFill>
-                  <a:schemeClr val="dk1"/>
-                </a:solidFill>
-                <a:effectLst/>
-                <a:uFillTx/>
-                <a:latin typeface="Calibri"/>
+              <a:rPr lang="pt-BR" sz="2400" b="0" u="none" strike="noStrike">
+                <a:solidFill>
+                  <a:srgbClr val="000000"/>
+                </a:solidFill>
+                <a:effectLst/>
+                <a:uFillTx/>
+                <a:latin typeface="Arial"/>
               </a:rPr>
               <a:t>3.º nível de tópicos</a:t>
             </a:r>
-            <a:endParaRPr lang="pt-BR" sz="2000" b="0" u="none" strike="noStrike">
-              <a:solidFill>
-                <a:schemeClr val="dk1"/>
-              </a:solidFill>
-              <a:effectLst/>
-              <a:uFillTx/>
-              <a:latin typeface="Calibri"/>
+            <a:endParaRPr lang="pt-BR" sz="2400" b="0" u="none" strike="noStrike">
+              <a:solidFill>
+                <a:srgbClr val="000000"/>
+              </a:solidFill>
+              <a:effectLst/>
+              <a:uFillTx/>
+              <a:latin typeface="Arial"/>
             </a:endParaRPr>
           </a:p>
           <a:p>
@@ -3222,21 +3657,21 @@
             <a:r>
               <a:rPr lang="pt-BR" sz="2000" b="0" u="none" strike="noStrike">
                 <a:solidFill>
-                  <a:schemeClr val="dk1"/>
-                </a:solidFill>
-                <a:effectLst/>
-                <a:uFillTx/>
-                <a:latin typeface="Calibri"/>
+                  <a:srgbClr val="000000"/>
+                </a:solidFill>
+                <a:effectLst/>
+                <a:uFillTx/>
+                <a:latin typeface="Arial"/>
               </a:rPr>
               <a:t>4.º nível de tópicos</a:t>
             </a:r>
             <a:endParaRPr lang="pt-BR" sz="2000" b="0" u="none" strike="noStrike">
               <a:solidFill>
-                <a:schemeClr val="dk1"/>
-              </a:solidFill>
-              <a:effectLst/>
-              <a:uFillTx/>
-              <a:latin typeface="Calibri"/>
+                <a:srgbClr val="000000"/>
+              </a:solidFill>
+              <a:effectLst/>
+              <a:uFillTx/>
+              <a:latin typeface="Arial"/>
             </a:endParaRPr>
           </a:p>
           <a:p>
@@ -3254,21 +3689,21 @@
             <a:r>
               <a:rPr lang="pt-BR" sz="2000" b="0" u="none" strike="noStrike">
                 <a:solidFill>
-                  <a:schemeClr val="dk1"/>
-                </a:solidFill>
-                <a:effectLst/>
-                <a:uFillTx/>
-                <a:latin typeface="Calibri"/>
+                  <a:srgbClr val="000000"/>
+                </a:solidFill>
+                <a:effectLst/>
+                <a:uFillTx/>
+                <a:latin typeface="Arial"/>
               </a:rPr>
               <a:t>5.º nível de tópicos</a:t>
             </a:r>
             <a:endParaRPr lang="pt-BR" sz="2000" b="0" u="none" strike="noStrike">
               <a:solidFill>
-                <a:schemeClr val="dk1"/>
-              </a:solidFill>
-              <a:effectLst/>
-              <a:uFillTx/>
-              <a:latin typeface="Calibri"/>
+                <a:srgbClr val="000000"/>
+              </a:solidFill>
+              <a:effectLst/>
+              <a:uFillTx/>
+              <a:latin typeface="Arial"/>
             </a:endParaRPr>
           </a:p>
           <a:p>
@@ -3286,21 +3721,21 @@
             <a:r>
               <a:rPr lang="pt-BR" sz="2000" b="0" u="none" strike="noStrike">
                 <a:solidFill>
-                  <a:schemeClr val="dk1"/>
-                </a:solidFill>
-                <a:effectLst/>
-                <a:uFillTx/>
-                <a:latin typeface="Calibri"/>
+                  <a:srgbClr val="000000"/>
+                </a:solidFill>
+                <a:effectLst/>
+                <a:uFillTx/>
+                <a:latin typeface="Arial"/>
               </a:rPr>
               <a:t>6.º nível de tópicos</a:t>
             </a:r>
             <a:endParaRPr lang="pt-BR" sz="2000" b="0" u="none" strike="noStrike">
               <a:solidFill>
-                <a:schemeClr val="dk1"/>
-              </a:solidFill>
-              <a:effectLst/>
-              <a:uFillTx/>
-              <a:latin typeface="Calibri"/>
+                <a:srgbClr val="000000"/>
+              </a:solidFill>
+              <a:effectLst/>
+              <a:uFillTx/>
+              <a:latin typeface="Arial"/>
             </a:endParaRPr>
           </a:p>
           <a:p>
@@ -3318,21 +3753,21 @@
             <a:r>
               <a:rPr lang="pt-BR" sz="2000" b="0" u="none" strike="noStrike">
                 <a:solidFill>
-                  <a:schemeClr val="dk1"/>
-                </a:solidFill>
-                <a:effectLst/>
-                <a:uFillTx/>
-                <a:latin typeface="Calibri"/>
+                  <a:srgbClr val="000000"/>
+                </a:solidFill>
+                <a:effectLst/>
+                <a:uFillTx/>
+                <a:latin typeface="Arial"/>
               </a:rPr>
               <a:t>7.º nível de tópicos</a:t>
             </a:r>
             <a:endParaRPr lang="pt-BR" sz="2000" b="0" u="none" strike="noStrike">
               <a:solidFill>
-                <a:schemeClr val="dk1"/>
-              </a:solidFill>
-              <a:effectLst/>
-              <a:uFillTx/>
-              <a:latin typeface="Calibri"/>
+                <a:srgbClr val="000000"/>
+              </a:solidFill>
+              <a:effectLst/>
+              <a:uFillTx/>
+              <a:latin typeface="Arial"/>
             </a:endParaRPr>
           </a:p>
         </p:txBody>
@@ -3379,7 +3814,7 @@
         <p:spPr>
           <a:xfrm>
             <a:off x="8778240" y="-1800000"/>
-            <a:ext cx="5943240" cy="5943240"/>
+            <a:ext cx="5942880" cy="5942880"/>
           </a:xfrm>
           <a:prstGeom prst="ellipse">
             <a:avLst/>
@@ -3404,6 +3839,11 @@
             <a:noAutofit/>
           </a:bodyPr>
           <a:p>
+            <a:pPr>
+              <a:lnSpc>
+                <a:spcPct val="100000"/>
+              </a:lnSpc>
+            </a:pPr>
             <a:endParaRPr lang="pt-BR" sz="1800" b="0" u="none" strike="noStrike">
               <a:solidFill>
                 <a:srgbClr val="ffffff"/>
@@ -3424,7 +3864,7 @@
         <p:spPr>
           <a:xfrm>
             <a:off x="10058400" y="3931920"/>
-            <a:ext cx="3840120" cy="3840120"/>
+            <a:ext cx="3839760" cy="3839760"/>
           </a:xfrm>
           <a:prstGeom prst="ellipse">
             <a:avLst/>
@@ -3449,6 +3889,11 @@
             <a:noAutofit/>
           </a:bodyPr>
           <a:p>
+            <a:pPr>
+              <a:lnSpc>
+                <a:spcPct val="100000"/>
+              </a:lnSpc>
+            </a:pPr>
             <a:endParaRPr lang="pt-BR" sz="1800" b="0" u="none" strike="noStrike">
               <a:solidFill>
                 <a:srgbClr val="ffffff"/>
@@ -3469,7 +3914,7 @@
         <p:spPr>
           <a:xfrm>
             <a:off x="-1463040" y="4663440"/>
-            <a:ext cx="3108600" cy="3108600"/>
+            <a:ext cx="3108240" cy="3108240"/>
           </a:xfrm>
           <a:prstGeom prst="ellipse">
             <a:avLst/>
@@ -3494,6 +3939,11 @@
             <a:noAutofit/>
           </a:bodyPr>
           <a:p>
+            <a:pPr>
+              <a:lnSpc>
+                <a:spcPct val="100000"/>
+              </a:lnSpc>
+            </a:pPr>
             <a:endParaRPr lang="pt-BR" sz="1800" b="0" u="none" strike="noStrike">
               <a:solidFill>
                 <a:srgbClr val="ffffff"/>
@@ -3514,7 +3964,7 @@
         <p:spPr>
           <a:xfrm>
             <a:off x="822960" y="2340000"/>
-            <a:ext cx="7314840" cy="319680"/>
+            <a:ext cx="7314480" cy="319320"/>
           </a:xfrm>
           <a:prstGeom prst="rect">
             <a:avLst/>
@@ -3587,7 +4037,7 @@
         <p:spPr>
           <a:xfrm>
             <a:off x="0" y="2468880"/>
-            <a:ext cx="8640000" cy="1188360"/>
+            <a:ext cx="8639640" cy="1188000"/>
           </a:xfrm>
           <a:prstGeom prst="rect">
             <a:avLst/>
@@ -3608,7 +4058,11 @@
             <a:noAutofit/>
           </a:bodyPr>
           <a:p>
-            <a:pPr algn="r"/>
+            <a:pPr algn="r">
+              <a:lnSpc>
+                <a:spcPct val="100000"/>
+              </a:lnSpc>
+            </a:pPr>
             <a:r>
               <a:rPr lang="pt-BR" sz="4600" b="1" u="none" strike="noStrike">
                 <a:solidFill>
@@ -3619,7 +4073,7 @@
                 <a:latin typeface="Cambria"/>
                 <a:ea typeface="Cambria"/>
               </a:rPr>
-              <a:t>Pré-processamento de Dados</a:t>
+              <a:t>      Pré-processamento de Dados</a:t>
             </a:r>
             <a:endParaRPr lang="pt-BR" sz="4600" b="0" u="none" strike="noStrike">
               <a:solidFill>
@@ -3641,7 +4095,7 @@
         <p:spPr>
           <a:xfrm>
             <a:off x="822960" y="3408840"/>
-            <a:ext cx="8686440" cy="731160"/>
+            <a:ext cx="8686080" cy="730800"/>
           </a:xfrm>
           <a:prstGeom prst="rect">
             <a:avLst/>
@@ -3726,7 +4180,7 @@
         <p:spPr>
           <a:xfrm>
             <a:off x="822960" y="5943600"/>
-            <a:ext cx="10515240" cy="365400"/>
+            <a:ext cx="10514880" cy="365040"/>
           </a:xfrm>
           <a:prstGeom prst="rect">
             <a:avLst/>
@@ -3805,13 +4259,13 @@
       <p:sp>
         <p:nvSpPr>
           <p:cNvPr id="17" name=""/>
-          <p:cNvSpPr txBox="1"/>
+          <p:cNvSpPr/>
           <p:nvPr/>
         </p:nvSpPr>
         <p:spPr>
           <a:xfrm>
             <a:off x="4809240" y="6480000"/>
-            <a:ext cx="2573640" cy="346320"/>
+            <a:ext cx="2573280" cy="345960"/>
           </a:xfrm>
           <a:prstGeom prst="rect">
             <a:avLst/>
@@ -3821,11 +4275,22 @@
             <a:noFill/>
           </a:ln>
         </p:spPr>
+        <p:style>
+          <a:lnRef idx="0"/>
+          <a:fillRef idx="0"/>
+          <a:effectRef idx="0"/>
+          <a:fontRef idx="minor"/>
+        </p:style>
         <p:txBody>
           <a:bodyPr wrap="none" lIns="90000" rIns="90000" tIns="45000" bIns="45000" anchor="t">
             <a:spAutoFit/>
           </a:bodyPr>
           <a:p>
+            <a:pPr>
+              <a:lnSpc>
+                <a:spcPct val="100000"/>
+              </a:lnSpc>
+            </a:pPr>
             <a:r>
               <a:rPr lang="pt-BR" sz="1800" b="0" u="none" strike="noStrike">
                 <a:solidFill>
@@ -3835,62 +4300,7 @@
                 <a:uFillTx/>
                 <a:latin typeface="Arial"/>
               </a:rPr>
-              <a:t>FELI</a:t>
-            </a:r>
-            <a:r>
-              <a:rPr lang="pt-BR" sz="1800" b="0" u="none" strike="noStrike">
-                <a:solidFill>
-                  <a:srgbClr val="ffffff"/>
-                </a:solidFill>
-                <a:effectLst/>
-                <a:uFillTx/>
-                <a:latin typeface="Arial"/>
-              </a:rPr>
-              <a:t>PE </a:t>
-            </a:r>
-            <a:r>
-              <a:rPr lang="pt-BR" sz="1800" b="0" u="none" strike="noStrike">
-                <a:solidFill>
-                  <a:srgbClr val="ffffff"/>
-                </a:solidFill>
-                <a:effectLst/>
-                <a:uFillTx/>
-                <a:latin typeface="Arial"/>
-              </a:rPr>
-              <a:t>LIRA </a:t>
-            </a:r>
-            <a:r>
-              <a:rPr lang="pt-BR" sz="1800" b="0" u="none" strike="noStrike">
-                <a:solidFill>
-                  <a:srgbClr val="ffffff"/>
-                </a:solidFill>
-                <a:effectLst/>
-                <a:uFillTx/>
-                <a:latin typeface="Arial"/>
-              </a:rPr>
-              <a:t>DA </a:t>
-            </a:r>
-            <a:r>
-              <a:rPr lang="pt-BR" sz="1800" b="0" u="none" strike="noStrike">
-                <a:solidFill>
-                  <a:srgbClr val="ffffff"/>
-                </a:solidFill>
-                <a:effectLst/>
-                <a:uFillTx/>
-                <a:latin typeface="Arial"/>
-              </a:rPr>
-              <a:t>SILV</a:t>
-            </a:r>
-            <a:r>
-              <a:rPr lang="pt-BR" sz="1800" b="0" u="none" strike="noStrike">
-                <a:solidFill>
-                  <a:srgbClr val="ffffff"/>
-                </a:solidFill>
-                <a:effectLst/>
-                <a:uFillTx/>
-                <a:latin typeface="Arial"/>
-              </a:rPr>
-              <a:t>A</a:t>
+              <a:t>FELIPE LIRA DA SILVA</a:t>
             </a:r>
             <a:endParaRPr lang="pt-BR" sz="1800" b="0" u="none" strike="noStrike">
               <a:solidFill>
@@ -3949,7 +4359,7 @@
         <p:spPr>
           <a:xfrm>
             <a:off x="-1828800" y="-2011680"/>
-            <a:ext cx="5486040" cy="5486040"/>
+            <a:ext cx="5485680" cy="5485680"/>
           </a:xfrm>
           <a:prstGeom prst="ellipse">
             <a:avLst/>
@@ -3974,6 +4384,11 @@
             <a:noAutofit/>
           </a:bodyPr>
           <a:p>
+            <a:pPr>
+              <a:lnSpc>
+                <a:spcPct val="100000"/>
+              </a:lnSpc>
+            </a:pPr>
             <a:endParaRPr lang="pt-BR" sz="1800" b="0" u="none" strike="noStrike">
               <a:solidFill>
                 <a:srgbClr val="ffffff"/>
@@ -3994,7 +4409,7 @@
         <p:spPr>
           <a:xfrm>
             <a:off x="9601200" y="3474720"/>
-            <a:ext cx="4754520" cy="4754520"/>
+            <a:ext cx="4754160" cy="4754160"/>
           </a:xfrm>
           <a:prstGeom prst="ellipse">
             <a:avLst/>
@@ -4019,6 +4434,11 @@
             <a:noAutofit/>
           </a:bodyPr>
           <a:p>
+            <a:pPr>
+              <a:lnSpc>
+                <a:spcPct val="100000"/>
+              </a:lnSpc>
+            </a:pPr>
             <a:endParaRPr lang="pt-BR" sz="1800" b="0" u="none" strike="noStrike">
               <a:solidFill>
                 <a:srgbClr val="ffffff"/>
@@ -4033,13 +4453,13 @@
       <p:sp>
         <p:nvSpPr>
           <p:cNvPr id="118" name=""/>
-          <p:cNvSpPr txBox="1"/>
+          <p:cNvSpPr/>
           <p:nvPr/>
         </p:nvSpPr>
         <p:spPr>
           <a:xfrm>
             <a:off x="2405880" y="2702520"/>
-            <a:ext cx="7380000" cy="1452960"/>
+            <a:ext cx="7379640" cy="1452600"/>
           </a:xfrm>
           <a:prstGeom prst="rect">
             <a:avLst/>
@@ -4049,11 +4469,22 @@
             <a:noFill/>
           </a:ln>
         </p:spPr>
+        <p:style>
+          <a:lnRef idx="0"/>
+          <a:fillRef idx="0"/>
+          <a:effectRef idx="0"/>
+          <a:fontRef idx="minor"/>
+        </p:style>
         <p:txBody>
           <a:bodyPr lIns="90000" rIns="90000" tIns="45000" bIns="45000" anchor="t">
             <a:spAutoFit/>
           </a:bodyPr>
           <a:p>
+            <a:pPr>
+              <a:lnSpc>
+                <a:spcPct val="100000"/>
+              </a:lnSpc>
+            </a:pPr>
             <a:r>
               <a:rPr lang="pt-BR" sz="9600" b="1" u="none" strike="noStrike">
                 <a:solidFill>
@@ -4063,42 +4494,9 @@
                 <a:uFillTx/>
                 <a:latin typeface="Arial"/>
               </a:rPr>
-              <a:t>OB</a:t>
-            </a:r>
-            <a:r>
-              <a:rPr lang="pt-BR" sz="9600" b="1" u="none" strike="noStrike">
-                <a:solidFill>
-                  <a:srgbClr val="ffffff"/>
-                </a:solidFill>
-                <a:effectLst/>
-                <a:uFillTx/>
-                <a:latin typeface="Arial"/>
-              </a:rPr>
-              <a:t>RIG</a:t>
-            </a:r>
-            <a:r>
-              <a:rPr lang="pt-BR" sz="9600" b="1" u="none" strike="noStrike">
-                <a:solidFill>
-                  <a:srgbClr val="ffffff"/>
-                </a:solidFill>
-                <a:effectLst/>
-                <a:uFillTx/>
-                <a:latin typeface="Arial"/>
-              </a:rPr>
-              <a:t>AD</a:t>
-            </a:r>
-            <a:r>
-              <a:rPr lang="pt-BR" sz="9600" b="1" u="none" strike="noStrike">
-                <a:solidFill>
-                  <a:srgbClr val="ffffff"/>
-                </a:solidFill>
-                <a:effectLst/>
-                <a:uFillTx/>
-                <a:latin typeface="Arial"/>
-              </a:rPr>
-              <a:t>O!</a:t>
-            </a:r>
-            <a:endParaRPr lang="pt-BR" sz="9600" b="1" u="none" strike="noStrike">
+              <a:t>OBRIGADO!</a:t>
+            </a:r>
+            <a:endParaRPr lang="pt-BR" sz="9600" b="0" u="none" strike="noStrike">
               <a:solidFill>
                 <a:srgbClr val="ffffff"/>
               </a:solidFill>
@@ -4155,7 +4553,7 @@
         <p:spPr>
           <a:xfrm>
             <a:off x="548640" y="457200"/>
-            <a:ext cx="7314840" cy="273960"/>
+            <a:ext cx="7314480" cy="273600"/>
           </a:xfrm>
           <a:prstGeom prst="rect">
             <a:avLst/>
@@ -4216,7 +4614,7 @@
         <p:spPr>
           <a:xfrm>
             <a:off x="548640" y="713160"/>
-            <a:ext cx="10423800" cy="548280"/>
+            <a:ext cx="10423440" cy="547920"/>
           </a:xfrm>
           <a:prstGeom prst="rect">
             <a:avLst/>
@@ -4276,7 +4674,7 @@
         </p:nvGraphicFramePr>
         <p:xfrm>
           <a:off x="548640" y="1508760"/>
-          <a:ext cx="5943240" cy="4869000"/>
+          <a:ext cx="5943240" cy="4869360"/>
         </p:xfrm>
         <a:graphic>
           <a:graphicData uri="http://schemas.openxmlformats.org/drawingml/2006/table">
@@ -5599,7 +5997,7 @@
         <p:spPr>
           <a:xfrm>
             <a:off x="6903720" y="1508760"/>
-            <a:ext cx="4754520" cy="1416960"/>
+            <a:ext cx="4754160" cy="1416600"/>
           </a:xfrm>
           <a:prstGeom prst="roundRect">
             <a:avLst>
@@ -5624,6 +6022,11 @@
             <a:noAutofit/>
           </a:bodyPr>
           <a:p>
+            <a:pPr>
+              <a:lnSpc>
+                <a:spcPct val="100000"/>
+              </a:lnSpc>
+            </a:pPr>
             <a:endParaRPr lang="pt-BR" sz="1800" b="0" u="none" strike="noStrike">
               <a:solidFill>
                 <a:srgbClr val="000000"/>
@@ -5644,7 +6047,7 @@
         <p:spPr>
           <a:xfrm>
             <a:off x="7178040" y="1627560"/>
-            <a:ext cx="4480200" cy="731160"/>
+            <a:ext cx="4479840" cy="730800"/>
           </a:xfrm>
           <a:prstGeom prst="rect">
             <a:avLst/>
@@ -5705,7 +6108,7 @@
         <p:spPr>
           <a:xfrm>
             <a:off x="7178040" y="2331720"/>
-            <a:ext cx="4480200" cy="548280"/>
+            <a:ext cx="4479840" cy="547920"/>
           </a:xfrm>
           <a:prstGeom prst="rect">
             <a:avLst/>
@@ -5796,7 +6199,7 @@
         <p:spPr>
           <a:xfrm>
             <a:off x="9464040" y="1627560"/>
-            <a:ext cx="2102760" cy="731160"/>
+            <a:ext cx="2102400" cy="730800"/>
           </a:xfrm>
           <a:prstGeom prst="rect">
             <a:avLst/>
@@ -5845,7 +6248,7 @@
         <p:spPr>
           <a:xfrm>
             <a:off x="9464040" y="2331720"/>
-            <a:ext cx="2102760" cy="548280"/>
+            <a:ext cx="2102400" cy="547920"/>
           </a:xfrm>
           <a:prstGeom prst="rect">
             <a:avLst/>
@@ -5894,7 +6297,7 @@
         <p:spPr>
           <a:xfrm>
             <a:off x="6903720" y="3246120"/>
-            <a:ext cx="4754520" cy="273960"/>
+            <a:ext cx="4754160" cy="273600"/>
           </a:xfrm>
           <a:prstGeom prst="rect">
             <a:avLst/>
@@ -5954,7 +6357,7 @@
         </p:nvGraphicFramePr>
         <p:xfrm>
           <a:off x="6903720" y="3566160"/>
-          <a:ext cx="4754520" cy="2834280"/>
+          <a:ext cx="4754160" cy="2833920"/>
         </p:xfrm>
         <a:graphic>
           <a:graphicData uri="http://schemas.openxmlformats.org/drawingml/2006/chart">
@@ -5971,7 +6374,7 @@
         <p:spPr>
           <a:xfrm>
             <a:off x="11548800" y="6446520"/>
-            <a:ext cx="365400" cy="273960"/>
+            <a:ext cx="365040" cy="273600"/>
           </a:xfrm>
           <a:prstGeom prst="rect">
             <a:avLst/>
@@ -6069,7 +6472,7 @@
         <p:spPr>
           <a:xfrm>
             <a:off x="548640" y="502920"/>
-            <a:ext cx="502560" cy="502560"/>
+            <a:ext cx="502200" cy="502200"/>
           </a:xfrm>
           <a:prstGeom prst="ellipse">
             <a:avLst/>
@@ -6092,6 +6495,11 @@
             <a:noAutofit/>
           </a:bodyPr>
           <a:p>
+            <a:pPr>
+              <a:lnSpc>
+                <a:spcPct val="100000"/>
+              </a:lnSpc>
+            </a:pPr>
             <a:endParaRPr lang="pt-BR" sz="1800" b="0" u="none" strike="noStrike">
               <a:solidFill>
                 <a:srgbClr val="ffffff"/>
@@ -6112,7 +6520,7 @@
         <p:spPr>
           <a:xfrm>
             <a:off x="548640" y="502920"/>
-            <a:ext cx="502560" cy="502560"/>
+            <a:ext cx="502200" cy="502200"/>
           </a:xfrm>
           <a:prstGeom prst="rect">
             <a:avLst/>
@@ -6173,7 +6581,7 @@
         <p:spPr>
           <a:xfrm>
             <a:off x="1234440" y="457200"/>
-            <a:ext cx="7314840" cy="273960"/>
+            <a:ext cx="7314480" cy="273600"/>
           </a:xfrm>
           <a:prstGeom prst="rect">
             <a:avLst/>
@@ -6234,7 +6642,7 @@
         <p:spPr>
           <a:xfrm>
             <a:off x="1234440" y="713160"/>
-            <a:ext cx="10423800" cy="548280"/>
+            <a:ext cx="10423440" cy="547920"/>
           </a:xfrm>
           <a:prstGeom prst="rect">
             <a:avLst/>
@@ -6295,7 +6703,7 @@
         <p:spPr>
           <a:xfrm>
             <a:off x="548640" y="1417320"/>
-            <a:ext cx="4297320" cy="1828440"/>
+            <a:ext cx="4296960" cy="1828080"/>
           </a:xfrm>
           <a:prstGeom prst="rect">
             <a:avLst/>
@@ -6356,7 +6764,7 @@
         <p:spPr>
           <a:xfrm>
             <a:off x="548640" y="3429000"/>
-            <a:ext cx="4297320" cy="2651400"/>
+            <a:ext cx="4296960" cy="2651040"/>
           </a:xfrm>
           <a:prstGeom prst="roundRect">
             <a:avLst>
@@ -6381,6 +6789,11 @@
             <a:noAutofit/>
           </a:bodyPr>
           <a:p>
+            <a:pPr>
+              <a:lnSpc>
+                <a:spcPct val="100000"/>
+              </a:lnSpc>
+            </a:pPr>
             <a:endParaRPr lang="pt-BR" sz="1800" b="0" u="none" strike="noStrike">
               <a:solidFill>
                 <a:srgbClr val="000000"/>
@@ -6401,7 +6814,7 @@
         <p:spPr>
           <a:xfrm>
             <a:off x="822960" y="3611880"/>
-            <a:ext cx="3748680" cy="273960"/>
+            <a:ext cx="3748320" cy="273600"/>
           </a:xfrm>
           <a:prstGeom prst="rect">
             <a:avLst/>
@@ -6462,7 +6875,7 @@
         <p:spPr>
           <a:xfrm>
             <a:off x="822960" y="3931920"/>
-            <a:ext cx="3748680" cy="2102760"/>
+            <a:ext cx="3748320" cy="2102400"/>
           </a:xfrm>
           <a:prstGeom prst="rect">
             <a:avLst/>
@@ -6483,6 +6896,11 @@
             <a:noAutofit/>
           </a:bodyPr>
           <a:p>
+            <a:pPr>
+              <a:lnSpc>
+                <a:spcPct val="100000"/>
+              </a:lnSpc>
+            </a:pPr>
             <a:r>
               <a:rPr lang="en-US" sz="1300" b="1" u="none" strike="noStrike">
                 <a:solidFill>
@@ -6517,6 +6935,11 @@
             </a:endParaRPr>
           </a:p>
           <a:p>
+            <a:pPr>
+              <a:lnSpc>
+                <a:spcPct val="100000"/>
+              </a:lnSpc>
+            </a:pPr>
             <a:r>
               <a:rPr lang="en-US" sz="1300" b="1" u="none" strike="noStrike">
                 <a:solidFill>
@@ -6602,7 +7025,7 @@
         </p:nvGraphicFramePr>
         <p:xfrm>
           <a:off x="5029200" y="1417320"/>
-          <a:ext cx="6583320" cy="4663080"/>
+          <a:ext cx="6582960" cy="4662720"/>
         </p:xfrm>
         <a:graphic>
           <a:graphicData uri="http://schemas.openxmlformats.org/drawingml/2006/chart">
@@ -6619,7 +7042,7 @@
         <p:spPr>
           <a:xfrm>
             <a:off x="11548800" y="6446520"/>
-            <a:ext cx="365400" cy="273960"/>
+            <a:ext cx="365040" cy="273600"/>
           </a:xfrm>
           <a:prstGeom prst="rect">
             <a:avLst/>
@@ -6717,7 +7140,7 @@
         <p:spPr>
           <a:xfrm>
             <a:off x="548640" y="502920"/>
-            <a:ext cx="502560" cy="502560"/>
+            <a:ext cx="502200" cy="502200"/>
           </a:xfrm>
           <a:prstGeom prst="ellipse">
             <a:avLst/>
@@ -6740,6 +7163,11 @@
             <a:noAutofit/>
           </a:bodyPr>
           <a:p>
+            <a:pPr>
+              <a:lnSpc>
+                <a:spcPct val="100000"/>
+              </a:lnSpc>
+            </a:pPr>
             <a:endParaRPr lang="pt-BR" sz="1800" b="0" u="none" strike="noStrike">
               <a:solidFill>
                 <a:srgbClr val="ffffff"/>
@@ -6760,7 +7188,7 @@
         <p:spPr>
           <a:xfrm>
             <a:off x="548640" y="502920"/>
-            <a:ext cx="502560" cy="502560"/>
+            <a:ext cx="502200" cy="502200"/>
           </a:xfrm>
           <a:prstGeom prst="rect">
             <a:avLst/>
@@ -6821,7 +7249,7 @@
         <p:spPr>
           <a:xfrm>
             <a:off x="1234440" y="457200"/>
-            <a:ext cx="7314840" cy="273960"/>
+            <a:ext cx="7314480" cy="273600"/>
           </a:xfrm>
           <a:prstGeom prst="rect">
             <a:avLst/>
@@ -6882,7 +7310,7 @@
         <p:spPr>
           <a:xfrm>
             <a:off x="1234440" y="713160"/>
-            <a:ext cx="10423800" cy="548280"/>
+            <a:ext cx="10423440" cy="547920"/>
           </a:xfrm>
           <a:prstGeom prst="rect">
             <a:avLst/>
@@ -6943,7 +7371,7 @@
         <p:spPr>
           <a:xfrm>
             <a:off x="548640" y="1463040"/>
-            <a:ext cx="10698120" cy="822600"/>
+            <a:ext cx="10697760" cy="822240"/>
           </a:xfrm>
           <a:prstGeom prst="rect">
             <a:avLst/>
@@ -7004,7 +7432,7 @@
         <p:spPr>
           <a:xfrm>
             <a:off x="548640" y="2514600"/>
-            <a:ext cx="5257440" cy="3565800"/>
+            <a:ext cx="5257080" cy="3565440"/>
           </a:xfrm>
           <a:prstGeom prst="roundRect">
             <a:avLst>
@@ -7029,6 +7457,11 @@
             <a:noAutofit/>
           </a:bodyPr>
           <a:p>
+            <a:pPr>
+              <a:lnSpc>
+                <a:spcPct val="100000"/>
+              </a:lnSpc>
+            </a:pPr>
             <a:endParaRPr lang="pt-BR" sz="1800" b="0" u="none" strike="noStrike">
               <a:solidFill>
                 <a:srgbClr val="000000"/>
@@ -7049,7 +7482,7 @@
         <p:spPr>
           <a:xfrm>
             <a:off x="868680" y="2724840"/>
-            <a:ext cx="4663080" cy="365400"/>
+            <a:ext cx="4662720" cy="365040"/>
           </a:xfrm>
           <a:prstGeom prst="rect">
             <a:avLst/>
@@ -7110,7 +7543,7 @@
         <p:spPr>
           <a:xfrm>
             <a:off x="868680" y="3063240"/>
-            <a:ext cx="4663080" cy="273960"/>
+            <a:ext cx="4662720" cy="273600"/>
           </a:xfrm>
           <a:prstGeom prst="rect">
             <a:avLst/>
@@ -7171,7 +7604,7 @@
         <p:spPr>
           <a:xfrm>
             <a:off x="868680" y="3429000"/>
-            <a:ext cx="4663080" cy="2468520"/>
+            <a:ext cx="4662720" cy="2468160"/>
           </a:xfrm>
           <a:prstGeom prst="rect">
             <a:avLst/>
@@ -7367,7 +7800,7 @@
         <p:spPr>
           <a:xfrm>
             <a:off x="6263640" y="2514600"/>
-            <a:ext cx="5348880" cy="3565800"/>
+            <a:ext cx="5348520" cy="3565440"/>
           </a:xfrm>
           <a:prstGeom prst="roundRect">
             <a:avLst>
@@ -7392,6 +7825,11 @@
             <a:noAutofit/>
           </a:bodyPr>
           <a:p>
+            <a:pPr>
+              <a:lnSpc>
+                <a:spcPct val="100000"/>
+              </a:lnSpc>
+            </a:pPr>
             <a:endParaRPr lang="pt-BR" sz="1800" b="0" u="none" strike="noStrike">
               <a:solidFill>
                 <a:srgbClr val="000000"/>
@@ -7412,7 +7850,7 @@
         <p:spPr>
           <a:xfrm>
             <a:off x="6583680" y="2724840"/>
-            <a:ext cx="4754520" cy="365400"/>
+            <a:ext cx="4754160" cy="365040"/>
           </a:xfrm>
           <a:prstGeom prst="rect">
             <a:avLst/>
@@ -7473,7 +7911,7 @@
         <p:spPr>
           <a:xfrm>
             <a:off x="6583680" y="3063240"/>
-            <a:ext cx="4754520" cy="273960"/>
+            <a:ext cx="4754160" cy="273600"/>
           </a:xfrm>
           <a:prstGeom prst="rect">
             <a:avLst/>
@@ -7534,7 +7972,7 @@
         <p:spPr>
           <a:xfrm>
             <a:off x="6583680" y="3429000"/>
-            <a:ext cx="4754520" cy="2468520"/>
+            <a:ext cx="4754160" cy="2468160"/>
           </a:xfrm>
           <a:prstGeom prst="rect">
             <a:avLst/>
@@ -7697,7 +8135,7 @@
         <p:spPr>
           <a:xfrm>
             <a:off x="11548800" y="6446520"/>
-            <a:ext cx="365400" cy="273960"/>
+            <a:ext cx="365040" cy="273600"/>
           </a:xfrm>
           <a:prstGeom prst="rect">
             <a:avLst/>
@@ -7795,7 +8233,7 @@
         <p:spPr>
           <a:xfrm>
             <a:off x="548640" y="502920"/>
-            <a:ext cx="502560" cy="502560"/>
+            <a:ext cx="502200" cy="502200"/>
           </a:xfrm>
           <a:prstGeom prst="ellipse">
             <a:avLst/>
@@ -7818,6 +8256,11 @@
             <a:noAutofit/>
           </a:bodyPr>
           <a:p>
+            <a:pPr>
+              <a:lnSpc>
+                <a:spcPct val="100000"/>
+              </a:lnSpc>
+            </a:pPr>
             <a:endParaRPr lang="pt-BR" sz="1800" b="0" u="none" strike="noStrike">
               <a:solidFill>
                 <a:srgbClr val="ffffff"/>
@@ -7838,7 +8281,7 @@
         <p:spPr>
           <a:xfrm>
             <a:off x="548640" y="502920"/>
-            <a:ext cx="502560" cy="502560"/>
+            <a:ext cx="502200" cy="502200"/>
           </a:xfrm>
           <a:prstGeom prst="rect">
             <a:avLst/>
@@ -7887,7 +8330,7 @@
         <p:spPr>
           <a:xfrm>
             <a:off x="1234440" y="457200"/>
-            <a:ext cx="7314840" cy="273960"/>
+            <a:ext cx="7314480" cy="273600"/>
           </a:xfrm>
           <a:prstGeom prst="rect">
             <a:avLst/>
@@ -7948,7 +8391,7 @@
         <p:spPr>
           <a:xfrm>
             <a:off x="1234440" y="713160"/>
-            <a:ext cx="10423800" cy="548280"/>
+            <a:ext cx="10423440" cy="547920"/>
           </a:xfrm>
           <a:prstGeom prst="rect">
             <a:avLst/>
@@ -8009,7 +8452,7 @@
         <p:spPr>
           <a:xfrm>
             <a:off x="548640" y="1417320"/>
-            <a:ext cx="10698120" cy="776880"/>
+            <a:ext cx="10697760" cy="776520"/>
           </a:xfrm>
           <a:prstGeom prst="rect">
             <a:avLst/>
@@ -8069,7 +8512,7 @@
         </p:nvGraphicFramePr>
         <p:xfrm>
           <a:off x="548640" y="2331720"/>
-          <a:ext cx="7223400" cy="3977280"/>
+          <a:ext cx="7223040" cy="3976920"/>
         </p:xfrm>
         <a:graphic>
           <a:graphicData uri="http://schemas.openxmlformats.org/drawingml/2006/chart">
@@ -8086,7 +8529,7 @@
         <p:spPr>
           <a:xfrm>
             <a:off x="8001000" y="2331720"/>
-            <a:ext cx="3611520" cy="1782720"/>
+            <a:ext cx="3611160" cy="1782360"/>
           </a:xfrm>
           <a:prstGeom prst="roundRect">
             <a:avLst>
@@ -8111,6 +8554,11 @@
             <a:noAutofit/>
           </a:bodyPr>
           <a:p>
+            <a:pPr>
+              <a:lnSpc>
+                <a:spcPct val="100000"/>
+              </a:lnSpc>
+            </a:pPr>
             <a:endParaRPr lang="pt-BR" sz="1800" b="0" u="none" strike="noStrike">
               <a:solidFill>
                 <a:srgbClr val="000000"/>
@@ -8131,7 +8579,7 @@
         <p:spPr>
           <a:xfrm>
             <a:off x="8229600" y="2487240"/>
-            <a:ext cx="3200040" cy="292320"/>
+            <a:ext cx="3199680" cy="291960"/>
           </a:xfrm>
           <a:prstGeom prst="rect">
             <a:avLst/>
@@ -8192,7 +8640,7 @@
         <p:spPr>
           <a:xfrm>
             <a:off x="8229600" y="2816280"/>
-            <a:ext cx="3200040" cy="1188360"/>
+            <a:ext cx="3199680" cy="1188000"/>
           </a:xfrm>
           <a:prstGeom prst="rect">
             <a:avLst/>
@@ -8253,7 +8701,7 @@
         <p:spPr>
           <a:xfrm>
             <a:off x="8001000" y="4297680"/>
-            <a:ext cx="3611520" cy="2011320"/>
+            <a:ext cx="3611160" cy="2010960"/>
           </a:xfrm>
           <a:prstGeom prst="roundRect">
             <a:avLst>
@@ -8278,6 +8726,11 @@
             <a:noAutofit/>
           </a:bodyPr>
           <a:p>
+            <a:pPr>
+              <a:lnSpc>
+                <a:spcPct val="100000"/>
+              </a:lnSpc>
+            </a:pPr>
             <a:endParaRPr lang="pt-BR" sz="1800" b="0" u="none" strike="noStrike">
               <a:solidFill>
                 <a:srgbClr val="000000"/>
@@ -8298,7 +8751,7 @@
         <p:spPr>
           <a:xfrm>
             <a:off x="8229600" y="4462200"/>
-            <a:ext cx="3200040" cy="292320"/>
+            <a:ext cx="3199680" cy="291960"/>
           </a:xfrm>
           <a:prstGeom prst="rect">
             <a:avLst/>
@@ -8359,7 +8812,7 @@
         <p:spPr>
           <a:xfrm>
             <a:off x="8229600" y="4791600"/>
-            <a:ext cx="3200040" cy="1371240"/>
+            <a:ext cx="3199680" cy="1370880"/>
           </a:xfrm>
           <a:prstGeom prst="rect">
             <a:avLst/>
@@ -8420,7 +8873,7 @@
         <p:spPr>
           <a:xfrm>
             <a:off x="11548800" y="6446520"/>
-            <a:ext cx="365400" cy="273960"/>
+            <a:ext cx="365040" cy="273600"/>
           </a:xfrm>
           <a:prstGeom prst="rect">
             <a:avLst/>
@@ -8518,7 +8971,7 @@
         <p:spPr>
           <a:xfrm>
             <a:off x="548640" y="502920"/>
-            <a:ext cx="502560" cy="502560"/>
+            <a:ext cx="502200" cy="502200"/>
           </a:xfrm>
           <a:prstGeom prst="ellipse">
             <a:avLst/>
@@ -8541,6 +8994,11 @@
             <a:noAutofit/>
           </a:bodyPr>
           <a:p>
+            <a:pPr>
+              <a:lnSpc>
+                <a:spcPct val="100000"/>
+              </a:lnSpc>
+            </a:pPr>
             <a:endParaRPr lang="pt-BR" sz="1800" b="0" u="none" strike="noStrike">
               <a:solidFill>
                 <a:srgbClr val="ffffff"/>
@@ -8561,7 +9019,7 @@
         <p:spPr>
           <a:xfrm>
             <a:off x="620640" y="502920"/>
-            <a:ext cx="502560" cy="502560"/>
+            <a:ext cx="502200" cy="502200"/>
           </a:xfrm>
           <a:prstGeom prst="rect">
             <a:avLst/>
@@ -8610,7 +9068,7 @@
         <p:spPr>
           <a:xfrm>
             <a:off x="1234440" y="457200"/>
-            <a:ext cx="7314840" cy="273960"/>
+            <a:ext cx="7314480" cy="273600"/>
           </a:xfrm>
           <a:prstGeom prst="rect">
             <a:avLst/>
@@ -8671,7 +9129,7 @@
         <p:spPr>
           <a:xfrm>
             <a:off x="1234440" y="713160"/>
-            <a:ext cx="10423800" cy="548280"/>
+            <a:ext cx="10423440" cy="547920"/>
           </a:xfrm>
           <a:prstGeom prst="rect">
             <a:avLst/>
@@ -8732,7 +9190,7 @@
         <p:spPr>
           <a:xfrm>
             <a:off x="548640" y="1417320"/>
-            <a:ext cx="10698120" cy="868320"/>
+            <a:ext cx="10697760" cy="867960"/>
           </a:xfrm>
           <a:prstGeom prst="rect">
             <a:avLst/>
@@ -8793,7 +9251,7 @@
         <p:spPr>
           <a:xfrm>
             <a:off x="548640" y="2514600"/>
-            <a:ext cx="5257440" cy="3565800"/>
+            <a:ext cx="5257080" cy="3565440"/>
           </a:xfrm>
           <a:prstGeom prst="roundRect">
             <a:avLst>
@@ -8818,6 +9276,11 @@
             <a:noAutofit/>
           </a:bodyPr>
           <a:p>
+            <a:pPr>
+              <a:lnSpc>
+                <a:spcPct val="100000"/>
+              </a:lnSpc>
+            </a:pPr>
             <a:endParaRPr lang="pt-BR" sz="1800" b="0" u="none" strike="noStrike">
               <a:solidFill>
                 <a:srgbClr val="000000"/>
@@ -8838,7 +9301,7 @@
         <p:spPr>
           <a:xfrm>
             <a:off x="868680" y="2724840"/>
-            <a:ext cx="4663080" cy="319680"/>
+            <a:ext cx="4662720" cy="319320"/>
           </a:xfrm>
           <a:prstGeom prst="rect">
             <a:avLst/>
@@ -8899,7 +9362,7 @@
         <p:spPr>
           <a:xfrm>
             <a:off x="868680" y="3063240"/>
-            <a:ext cx="4663080" cy="456840"/>
+            <a:ext cx="4662720" cy="456480"/>
           </a:xfrm>
           <a:prstGeom prst="rect">
             <a:avLst/>
@@ -8960,7 +9423,7 @@
         <p:spPr>
           <a:xfrm>
             <a:off x="868680" y="3657600"/>
-            <a:ext cx="4663080" cy="2194200"/>
+            <a:ext cx="4662720" cy="2193840"/>
           </a:xfrm>
           <a:prstGeom prst="rect">
             <a:avLst/>
@@ -8981,6 +9444,11 @@
             <a:noAutofit/>
           </a:bodyPr>
           <a:p>
+            <a:pPr>
+              <a:lnSpc>
+                <a:spcPct val="100000"/>
+              </a:lnSpc>
+            </a:pPr>
             <a:r>
               <a:rPr lang="en-US" sz="1350" b="0" u="none" strike="noStrike">
                 <a:solidFill>
@@ -9003,6 +9471,11 @@
             </a:endParaRPr>
           </a:p>
           <a:p>
+            <a:pPr>
+              <a:lnSpc>
+                <a:spcPct val="100000"/>
+              </a:lnSpc>
+            </a:pPr>
             <a:r>
               <a:rPr lang="en-US" sz="1350" b="0" u="none" strike="noStrike">
                 <a:solidFill>
@@ -9068,7 +9541,7 @@
         <p:spPr>
           <a:xfrm>
             <a:off x="6263640" y="2514600"/>
-            <a:ext cx="5348880" cy="3565800"/>
+            <a:ext cx="5348520" cy="3565440"/>
           </a:xfrm>
           <a:prstGeom prst="roundRect">
             <a:avLst>
@@ -9093,6 +9566,11 @@
             <a:noAutofit/>
           </a:bodyPr>
           <a:p>
+            <a:pPr>
+              <a:lnSpc>
+                <a:spcPct val="100000"/>
+              </a:lnSpc>
+            </a:pPr>
             <a:endParaRPr lang="pt-BR" sz="1800" b="0" u="none" strike="noStrike">
               <a:solidFill>
                 <a:srgbClr val="000000"/>
@@ -9113,7 +9591,7 @@
         <p:spPr>
           <a:xfrm>
             <a:off x="6583680" y="2724840"/>
-            <a:ext cx="4754520" cy="319680"/>
+            <a:ext cx="4754160" cy="319320"/>
           </a:xfrm>
           <a:prstGeom prst="rect">
             <a:avLst/>
@@ -9174,7 +9652,7 @@
         <p:spPr>
           <a:xfrm>
             <a:off x="6583680" y="3063240"/>
-            <a:ext cx="4754520" cy="456840"/>
+            <a:ext cx="4754160" cy="456480"/>
           </a:xfrm>
           <a:prstGeom prst="rect">
             <a:avLst/>
@@ -9235,7 +9713,7 @@
         <p:spPr>
           <a:xfrm>
             <a:off x="6583680" y="3657600"/>
-            <a:ext cx="4754520" cy="2194200"/>
+            <a:ext cx="4754160" cy="2193840"/>
           </a:xfrm>
           <a:prstGeom prst="rect">
             <a:avLst/>
@@ -9256,6 +9734,11 @@
             <a:noAutofit/>
           </a:bodyPr>
           <a:p>
+            <a:pPr>
+              <a:lnSpc>
+                <a:spcPct val="100000"/>
+              </a:lnSpc>
+            </a:pPr>
             <a:r>
               <a:rPr lang="en-US" sz="1350" b="0" u="none" strike="noStrike">
                 <a:solidFill>
@@ -9278,6 +9761,11 @@
             </a:endParaRPr>
           </a:p>
           <a:p>
+            <a:pPr>
+              <a:lnSpc>
+                <a:spcPct val="100000"/>
+              </a:lnSpc>
+            </a:pPr>
             <a:r>
               <a:rPr lang="en-US" sz="1350" b="0" u="none" strike="noStrike">
                 <a:solidFill>
@@ -9343,7 +9831,7 @@
         <p:spPr>
           <a:xfrm>
             <a:off x="11548800" y="6446520"/>
-            <a:ext cx="365400" cy="273960"/>
+            <a:ext cx="365040" cy="273600"/>
           </a:xfrm>
           <a:prstGeom prst="rect">
             <a:avLst/>
@@ -9441,7 +9929,7 @@
         <p:spPr>
           <a:xfrm>
             <a:off x="548640" y="502920"/>
-            <a:ext cx="502560" cy="502560"/>
+            <a:ext cx="502200" cy="502200"/>
           </a:xfrm>
           <a:prstGeom prst="ellipse">
             <a:avLst/>
@@ -9464,6 +9952,11 @@
             <a:noAutofit/>
           </a:bodyPr>
           <a:p>
+            <a:pPr>
+              <a:lnSpc>
+                <a:spcPct val="100000"/>
+              </a:lnSpc>
+            </a:pPr>
             <a:endParaRPr lang="pt-BR" sz="1800" b="0" u="none" strike="noStrike">
               <a:solidFill>
                 <a:srgbClr val="ffffff"/>
@@ -9484,7 +9977,7 @@
         <p:spPr>
           <a:xfrm>
             <a:off x="548640" y="502920"/>
-            <a:ext cx="502560" cy="502560"/>
+            <a:ext cx="502200" cy="502200"/>
           </a:xfrm>
           <a:prstGeom prst="rect">
             <a:avLst/>
@@ -9533,7 +10026,7 @@
         <p:spPr>
           <a:xfrm>
             <a:off x="1234440" y="457200"/>
-            <a:ext cx="7314840" cy="273960"/>
+            <a:ext cx="7314480" cy="273600"/>
           </a:xfrm>
           <a:prstGeom prst="rect">
             <a:avLst/>
@@ -9594,7 +10087,7 @@
         <p:spPr>
           <a:xfrm>
             <a:off x="1234440" y="713160"/>
-            <a:ext cx="10423800" cy="548280"/>
+            <a:ext cx="10423440" cy="547920"/>
           </a:xfrm>
           <a:prstGeom prst="rect">
             <a:avLst/>
@@ -9655,7 +10148,7 @@
         <p:spPr>
           <a:xfrm>
             <a:off x="548640" y="1417320"/>
-            <a:ext cx="10698120" cy="914040"/>
+            <a:ext cx="10697760" cy="913680"/>
           </a:xfrm>
           <a:prstGeom prst="rect">
             <a:avLst/>
@@ -9716,7 +10209,7 @@
         <p:spPr>
           <a:xfrm>
             <a:off x="548640" y="2606040"/>
-            <a:ext cx="5120280" cy="3428640"/>
+            <a:ext cx="5119920" cy="3428280"/>
           </a:xfrm>
           <a:prstGeom prst="roundRect">
             <a:avLst>
@@ -9741,6 +10234,11 @@
             <a:noAutofit/>
           </a:bodyPr>
           <a:p>
+            <a:pPr>
+              <a:lnSpc>
+                <a:spcPct val="100000"/>
+              </a:lnSpc>
+            </a:pPr>
             <a:endParaRPr lang="pt-BR" sz="1800" b="0" u="none" strike="noStrike">
               <a:solidFill>
                 <a:srgbClr val="000000"/>
@@ -9761,7 +10259,7 @@
         <p:spPr>
           <a:xfrm>
             <a:off x="868680" y="2788920"/>
-            <a:ext cx="4480200" cy="319680"/>
+            <a:ext cx="4479840" cy="319320"/>
           </a:xfrm>
           <a:prstGeom prst="rect">
             <a:avLst/>
@@ -9822,7 +10320,7 @@
         <p:spPr>
           <a:xfrm>
             <a:off x="868680" y="3246120"/>
-            <a:ext cx="4480200" cy="639720"/>
+            <a:ext cx="4479840" cy="639360"/>
           </a:xfrm>
           <a:prstGeom prst="rect">
             <a:avLst/>
@@ -9883,7 +10381,7 @@
         <p:spPr>
           <a:xfrm>
             <a:off x="868680" y="3931920"/>
-            <a:ext cx="4480200" cy="456840"/>
+            <a:ext cx="4479840" cy="456480"/>
           </a:xfrm>
           <a:prstGeom prst="rect">
             <a:avLst/>
@@ -9944,7 +10442,7 @@
         <p:spPr>
           <a:xfrm>
             <a:off x="868680" y="4572000"/>
-            <a:ext cx="4480200" cy="1279800"/>
+            <a:ext cx="4479840" cy="1279440"/>
           </a:xfrm>
           <a:prstGeom prst="rect">
             <a:avLst/>
@@ -10005,7 +10503,7 @@
         <p:spPr>
           <a:xfrm>
             <a:off x="6309360" y="4114800"/>
-            <a:ext cx="5028840" cy="1737000"/>
+            <a:ext cx="5028480" cy="1736640"/>
           </a:xfrm>
           <a:prstGeom prst="rect">
             <a:avLst/>
@@ -10054,7 +10552,7 @@
         <p:spPr>
           <a:xfrm>
             <a:off x="11548800" y="6446520"/>
-            <a:ext cx="365400" cy="273960"/>
+            <a:ext cx="365040" cy="273600"/>
           </a:xfrm>
           <a:prstGeom prst="rect">
             <a:avLst/>
@@ -10152,7 +10650,7 @@
         <p:spPr>
           <a:xfrm>
             <a:off x="548640" y="502920"/>
-            <a:ext cx="502560" cy="502560"/>
+            <a:ext cx="502200" cy="502200"/>
           </a:xfrm>
           <a:prstGeom prst="ellipse">
             <a:avLst/>
@@ -10175,6 +10673,11 @@
             <a:noAutofit/>
           </a:bodyPr>
           <a:p>
+            <a:pPr>
+              <a:lnSpc>
+                <a:spcPct val="100000"/>
+              </a:lnSpc>
+            </a:pPr>
             <a:endParaRPr lang="pt-BR" sz="1800" b="0" u="none" strike="noStrike">
               <a:solidFill>
                 <a:srgbClr val="ffffff"/>
@@ -10195,7 +10698,7 @@
         <p:spPr>
           <a:xfrm>
             <a:off x="548640" y="502920"/>
-            <a:ext cx="502560" cy="502560"/>
+            <a:ext cx="502200" cy="502200"/>
           </a:xfrm>
           <a:prstGeom prst="rect">
             <a:avLst/>
@@ -10244,7 +10747,7 @@
         <p:spPr>
           <a:xfrm>
             <a:off x="1234440" y="457200"/>
-            <a:ext cx="7314840" cy="273960"/>
+            <a:ext cx="7314480" cy="273600"/>
           </a:xfrm>
           <a:prstGeom prst="rect">
             <a:avLst/>
@@ -10305,7 +10808,7 @@
         <p:spPr>
           <a:xfrm>
             <a:off x="1234440" y="713160"/>
-            <a:ext cx="10423800" cy="548280"/>
+            <a:ext cx="10423440" cy="547920"/>
           </a:xfrm>
           <a:prstGeom prst="rect">
             <a:avLst/>
@@ -10402,7 +10905,7 @@
         <p:spPr>
           <a:xfrm>
             <a:off x="548640" y="1417320"/>
-            <a:ext cx="10698120" cy="776880"/>
+            <a:ext cx="10697760" cy="776520"/>
           </a:xfrm>
           <a:prstGeom prst="rect">
             <a:avLst/>
@@ -10643,7 +11146,7 @@
         <p:spPr>
           <a:xfrm>
             <a:off x="548640" y="2468880"/>
-            <a:ext cx="5028840" cy="3748680"/>
+            <a:ext cx="5028480" cy="3748320"/>
           </a:xfrm>
           <a:prstGeom prst="roundRect">
             <a:avLst>
@@ -10668,6 +11171,11 @@
             <a:noAutofit/>
           </a:bodyPr>
           <a:p>
+            <a:pPr>
+              <a:lnSpc>
+                <a:spcPct val="100000"/>
+              </a:lnSpc>
+            </a:pPr>
             <a:endParaRPr lang="pt-BR" sz="1800" b="0" u="none" strike="noStrike">
               <a:solidFill>
                 <a:srgbClr val="ffffff"/>
@@ -10688,7 +11196,7 @@
         <p:spPr>
           <a:xfrm>
             <a:off x="868680" y="2724840"/>
-            <a:ext cx="4388760" cy="292320"/>
+            <a:ext cx="4388400" cy="291960"/>
           </a:xfrm>
           <a:prstGeom prst="rect">
             <a:avLst/>
@@ -10749,7 +11257,7 @@
         <p:spPr>
           <a:xfrm>
             <a:off x="868680" y="3035880"/>
-            <a:ext cx="4388760" cy="319680"/>
+            <a:ext cx="4388400" cy="319320"/>
           </a:xfrm>
           <a:prstGeom prst="rect">
             <a:avLst/>
@@ -10810,7 +11318,7 @@
         <p:spPr>
           <a:xfrm>
             <a:off x="868680" y="3703320"/>
-            <a:ext cx="4480200" cy="2285640"/>
+            <a:ext cx="4479840" cy="2285280"/>
           </a:xfrm>
           <a:prstGeom prst="rect">
             <a:avLst/>
@@ -11006,7 +11514,7 @@
         <p:spPr>
           <a:xfrm>
             <a:off x="5715000" y="4023360"/>
-            <a:ext cx="914040" cy="639720"/>
+            <a:ext cx="913680" cy="639360"/>
           </a:xfrm>
           <a:prstGeom prst="rightArrow">
             <a:avLst>
@@ -11032,6 +11540,11 @@
             <a:noAutofit/>
           </a:bodyPr>
           <a:p>
+            <a:pPr>
+              <a:lnSpc>
+                <a:spcPct val="100000"/>
+              </a:lnSpc>
+            </a:pPr>
             <a:endParaRPr lang="pt-BR" sz="1800" b="0" u="none" strike="noStrike">
               <a:solidFill>
                 <a:srgbClr val="ffffff"/>
@@ -11052,7 +11565,7 @@
         <p:spPr>
           <a:xfrm>
             <a:off x="5486400" y="4727520"/>
-            <a:ext cx="1371240" cy="548280"/>
+            <a:ext cx="1370880" cy="547920"/>
           </a:xfrm>
           <a:prstGeom prst="rect">
             <a:avLst/>
@@ -11143,7 +11656,7 @@
         <p:spPr>
           <a:xfrm>
             <a:off x="6720840" y="2468880"/>
-            <a:ext cx="4937400" cy="3748680"/>
+            <a:ext cx="4937040" cy="3748320"/>
           </a:xfrm>
           <a:prstGeom prst="roundRect">
             <a:avLst>
@@ -11168,6 +11681,11 @@
             <a:noAutofit/>
           </a:bodyPr>
           <a:p>
+            <a:pPr>
+              <a:lnSpc>
+                <a:spcPct val="100000"/>
+              </a:lnSpc>
+            </a:pPr>
             <a:endParaRPr lang="pt-BR" sz="1800" b="0" u="none" strike="noStrike">
               <a:solidFill>
                 <a:srgbClr val="ffffff"/>
@@ -11188,7 +11706,7 @@
         <p:spPr>
           <a:xfrm>
             <a:off x="7040880" y="2724840"/>
-            <a:ext cx="4297320" cy="292320"/>
+            <a:ext cx="4296960" cy="291960"/>
           </a:xfrm>
           <a:prstGeom prst="rect">
             <a:avLst/>
@@ -11249,7 +11767,7 @@
         <p:spPr>
           <a:xfrm>
             <a:off x="7040880" y="3035880"/>
-            <a:ext cx="4297320" cy="319680"/>
+            <a:ext cx="4296960" cy="319320"/>
           </a:xfrm>
           <a:prstGeom prst="rect">
             <a:avLst/>
@@ -11310,7 +11828,7 @@
         <p:spPr>
           <a:xfrm>
             <a:off x="7040880" y="3703320"/>
-            <a:ext cx="4480200" cy="2285640"/>
+            <a:ext cx="4479840" cy="2285280"/>
           </a:xfrm>
           <a:prstGeom prst="rect">
             <a:avLst/>
@@ -11440,7 +11958,7 @@
         <p:spPr>
           <a:xfrm>
             <a:off x="11548800" y="6446520"/>
-            <a:ext cx="365400" cy="273960"/>
+            <a:ext cx="365040" cy="273600"/>
           </a:xfrm>
           <a:prstGeom prst="rect">
             <a:avLst/>
@@ -11538,7 +12056,7 @@
         <p:spPr>
           <a:xfrm>
             <a:off x="548640" y="430920"/>
-            <a:ext cx="502560" cy="502560"/>
+            <a:ext cx="502200" cy="502200"/>
           </a:xfrm>
           <a:prstGeom prst="ellipse">
             <a:avLst/>
@@ -11561,6 +12079,11 @@
             <a:noAutofit/>
           </a:bodyPr>
           <a:p>
+            <a:pPr>
+              <a:lnSpc>
+                <a:spcPct val="100000"/>
+              </a:lnSpc>
+            </a:pPr>
             <a:endParaRPr lang="pt-BR" sz="1800" b="0" u="none" strike="noStrike">
               <a:solidFill>
                 <a:srgbClr val="ffffff"/>
@@ -11581,7 +12104,7 @@
         <p:spPr>
           <a:xfrm>
             <a:off x="548640" y="502920"/>
-            <a:ext cx="502560" cy="502560"/>
+            <a:ext cx="502200" cy="502200"/>
           </a:xfrm>
           <a:prstGeom prst="rect">
             <a:avLst/>
@@ -11630,7 +12153,7 @@
         <p:spPr>
           <a:xfrm>
             <a:off x="1234440" y="457200"/>
-            <a:ext cx="7314840" cy="273960"/>
+            <a:ext cx="7314480" cy="273600"/>
           </a:xfrm>
           <a:prstGeom prst="rect">
             <a:avLst/>
@@ -11679,7 +12202,7 @@
         <p:spPr>
           <a:xfrm>
             <a:off x="1096200" y="396000"/>
-            <a:ext cx="10423800" cy="548280"/>
+            <a:ext cx="10423440" cy="547920"/>
           </a:xfrm>
           <a:prstGeom prst="rect">
             <a:avLst/>
@@ -11788,7 +12311,7 @@
         <p:spPr>
           <a:xfrm>
             <a:off x="11548800" y="6446520"/>
-            <a:ext cx="365400" cy="273960"/>
+            <a:ext cx="365040" cy="273600"/>
           </a:xfrm>
           <a:prstGeom prst="rect">
             <a:avLst/>
@@ -11853,7 +12376,7 @@
         <p:spPr>
           <a:xfrm>
             <a:off x="180000" y="4779720"/>
-            <a:ext cx="6122160" cy="1880280"/>
+            <a:ext cx="6121800" cy="1879920"/>
           </a:xfrm>
           <a:prstGeom prst="rect">
             <a:avLst/>
@@ -11877,7 +12400,7 @@
         <p:spPr>
           <a:xfrm>
             <a:off x="180000" y="1440000"/>
-            <a:ext cx="6122160" cy="3441960"/>
+            <a:ext cx="6121800" cy="3441600"/>
           </a:xfrm>
           <a:prstGeom prst="rect">
             <a:avLst/>
@@ -11901,7 +12424,7 @@
         <p:spPr>
           <a:xfrm>
             <a:off x="6492240" y="2520000"/>
-            <a:ext cx="5387760" cy="2160000"/>
+            <a:ext cx="5387400" cy="2159640"/>
           </a:xfrm>
           <a:prstGeom prst="rect">
             <a:avLst/>

</xml_diff>